<commit_message>
Set-up: Python 3.14.8, project environments in Positron, stack test report
- Python 3.14.8 (latest): all pinned course packages install and PyMC samples on it;
  Windows via the Python install manager, macOS via the python.org installer
- Step 4 uses the Positron project: Python: Create Environment (venv, requirements.txt);
  %pip and %run in the console work the same on Windows and macOS
- setup/test_stack.qmd: polars, plotnine and statsmodels on the Alpenglow data, rendered
  with Quarto (tested on Python 3.11 and 3.14.8)
- Slides, setup guide, check script and Session 1 lab made consistent

Co-Authored-By: Claude Opus 5.5 <noreply@anthropic.com>
Claude-Session: https://claude.ai/code/session_01TbrdxHn7W6FVXXnpqzNytd
</commit_message>
<xml_diff>
--- a/slides/01a_setup-and-registration_WT26-27.pptx
+++ b/slides/01a_setup-and-registration_WT26-27.pptx
@@ -909,7 +909,7 @@
           <a:lstStyle/>
           <a:p>
             <a:r>
-              <a:t>Python 3.13.16 (30 September 2026) is the last full maintenance release of 3.13 and runs every course package. Do not take the big yellow 3.14 button on python.org: PyMC-Marketing does not run on 3.14 yet. On Windows the box 'Add python.exe to PATH' is the step most often missed.</a:t>
+              <a:t>Python 3.14.8 (30 September 2026) is the latest release; every course package installs and runs on it. Windows and macOS do not come with Python, so it is always installed once. On Windows, python.org now distributes Python through the Python install manager, which installs and updates Python itself. Positron can also install Python for you: Command Palette, Python: Install Python via uv.</a:t>
             </a:r>
           </a:p>
         </p:txBody>
@@ -1049,7 +1049,7 @@
           <a:lstStyle/>
           <a:p>
             <a:r>
-              <a:t>The course repository is read-only for students: they pull updates before each session. Group repositories for the case study come later and use the same clicks plus commit and push.</a:t>
+              <a:t>The course repository is public: anyone can clone it without sign-in or access rights. Students pull updates before each session. The cloned folder is the project they open in Positron.</a:t>
             </a:r>
           </a:p>
         </p:txBody>
@@ -1119,7 +1119,7 @@
           <a:lstStyle/>
           <a:p>
             <a:r>
-              <a:t>Run the two lines in the Positron terminal, inside the course folder. The first line makes a private Python in the folder .venv, the second installs every package in requirements.txt into it. The first install takes a few minutes because PyMC is large. No activation step is needed, because the commands call the Python inside .venv directly.</a:t>
+              <a:t>Python: Create Environment makes a .venv inside the open project folder with the chosen Python, offers to install the packages from requirements.txt, and selects the new interpreter. The first install takes a few minutes because PyMC is large. If packages were not installed, the console line does it, on Windows and macOS alike.</a:t>
             </a:r>
           </a:p>
         </p:txBody>
@@ -1189,7 +1189,7 @@
           <a:lstStyle/>
           <a:p>
             <a:r>
-              <a:t>The script lives in setup/check_setup.py. Every line marked !! says what to fix. Alternatively open the file and press the Run button at the top right of the editor.</a:t>
+              <a:t>The script lives in setup/check_setup.py. Every line marked !! says what to fix. setup/test_stack.qmd then runs polars, plotnine and statsmodels on the course data and renders with Quarto. Alternatively open the file and press the Run button at the top right of the editor.</a:t>
             </a:r>
           </a:p>
         </p:txBody>
@@ -11932,7 +11932,7 @@
           <a:p>
             <a:r>
               <a:rPr sz="1600" lang="en-GB"/>
-              <a:t>Step 2: download and install Python 3.13.16</a:t>
+              <a:t>Step 2: install Python 3.14.8</a:t>
             </a:r>
           </a:p>
         </p:txBody>
@@ -12197,7 +12197,7 @@
                   <a:schemeClr val="tx2"/>
                 </a:solidFill>
               </a:rPr>
-              <a:t>Packages</a:t>
+              <a:t>Project</a:t>
             </a:r>
           </a:p>
         </p:txBody>
@@ -12503,7 +12503,7 @@
                   <a:schemeClr val="tx1"/>
                 </a:solidFill>
               </a:rPr>
-              <a:t>Windows installer (64-bit)</a:t>
+              <a:t>Python install manager</a:t>
             </a:r>
           </a:p>
           <a:p>
@@ -12523,7 +12523,7 @@
                   <a:schemeClr val="tx1"/>
                 </a:solidFill>
               </a:rPr>
-              <a:t>Run the downloaded .exe</a:t>
+              <a:t>Install it with a double-click</a:t>
             </a:r>
           </a:p>
           <a:p>
@@ -12543,9 +12543,260 @@
                   <a:schemeClr val="tx1"/>
                 </a:solidFill>
               </a:rPr>
-              <a:t>Tick “Add python.exe to PATH”</a:t>
-            </a:r>
-          </a:p>
+              <a:t>Then in a terminal: py install 3.14</a:t>
+            </a:r>
+          </a:p>
+        </p:txBody>
+      </p:sp>
+      <p:sp>
+        <p:nvSpPr>
+          <p:cNvPr id="21" name="Windows check box"/>
+          <p:cNvSpPr/>
+          <p:nvPr/>
+        </p:nvSpPr>
+        <p:spPr>
+          <a:xfrm>
+            <a:off x="457200" y="3749040"/>
+            <a:ext cx="4046220" cy="566928"/>
+          </a:xfrm>
+          <a:prstGeom prst="rect">
+            <a:avLst/>
+          </a:prstGeom>
+          <a:solidFill>
+            <a:schemeClr val="tx2"/>
+          </a:solidFill>
+          <a:ln>
+            <a:noFill/>
+          </a:ln>
+          <a:effectLst/>
+        </p:spPr>
+        <p:style>
+          <a:lnRef idx="1">
+            <a:schemeClr val="accent1"/>
+          </a:lnRef>
+          <a:fillRef idx="3">
+            <a:schemeClr val="accent1"/>
+          </a:fillRef>
+          <a:effectRef idx="2">
+            <a:schemeClr val="accent1"/>
+          </a:effectRef>
+          <a:fontRef idx="minor">
+            <a:schemeClr val="lt1"/>
+          </a:fontRef>
+        </p:style>
+        <p:txBody>
+          <a:bodyPr rtlCol="0" anchor="ctr"/>
+          <a:lstStyle/>
+          <a:p/>
+        </p:txBody>
+      </p:sp>
+      <p:sp>
+        <p:nvSpPr>
+          <p:cNvPr id="22" name="Windows check code"/>
+          <p:cNvSpPr txBox="1"/>
+          <p:nvPr/>
+        </p:nvSpPr>
+        <p:spPr>
+          <a:xfrm>
+            <a:off x="594360" y="3840480"/>
+            <a:ext cx="3771900" cy="384048"/>
+          </a:xfrm>
+          <a:prstGeom prst="rect">
+            <a:avLst/>
+          </a:prstGeom>
+          <a:noFill/>
+        </p:spPr>
+        <p:txBody>
+          <a:bodyPr wrap="square" lIns="0" rIns="0" tIns="0" bIns="0" anchor="t">
+            <a:noAutofit/>
+          </a:bodyPr>
+          <a:lstStyle/>
+          <a:p>
+            <a:pPr algn="l">
+              <a:spcAft>
+                <a:spcPts val="0"/>
+              </a:spcAft>
+            </a:pPr>
+            <a:r>
+              <a:rPr sz="1150" b="0" lang="en-GB">
+                <a:solidFill>
+                  <a:schemeClr val="bg1"/>
+                </a:solidFill>
+                <a:latin typeface="Consolas"/>
+              </a:rPr>
+              <a:t>py -3.14 --version</a:t>
+            </a:r>
+          </a:p>
+        </p:txBody>
+      </p:sp>
+      <p:sp>
+        <p:nvSpPr>
+          <p:cNvPr id="23" name="macOS card body"/>
+          <p:cNvSpPr/>
+          <p:nvPr/>
+        </p:nvSpPr>
+        <p:spPr>
+          <a:xfrm>
+            <a:off x="4640580" y="2194560"/>
+            <a:ext cx="4046220" cy="1463040"/>
+          </a:xfrm>
+          <a:prstGeom prst="rect">
+            <a:avLst/>
+          </a:prstGeom>
+          <a:solidFill>
+            <a:schemeClr val="bg2"/>
+          </a:solidFill>
+          <a:ln>
+            <a:noFill/>
+          </a:ln>
+          <a:effectLst/>
+        </p:spPr>
+        <p:style>
+          <a:lnRef idx="1">
+            <a:schemeClr val="accent1"/>
+          </a:lnRef>
+          <a:fillRef idx="3">
+            <a:schemeClr val="accent1"/>
+          </a:fillRef>
+          <a:effectRef idx="2">
+            <a:schemeClr val="accent1"/>
+          </a:effectRef>
+          <a:fontRef idx="minor">
+            <a:schemeClr val="lt1"/>
+          </a:fontRef>
+        </p:style>
+        <p:txBody>
+          <a:bodyPr rtlCol="0" anchor="ctr"/>
+          <a:lstStyle/>
+          <a:p/>
+        </p:txBody>
+      </p:sp>
+      <p:sp>
+        <p:nvSpPr>
+          <p:cNvPr id="24" name="macOS card header"/>
+          <p:cNvSpPr/>
+          <p:nvPr/>
+        </p:nvSpPr>
+        <p:spPr>
+          <a:xfrm>
+            <a:off x="4640580" y="1783080"/>
+            <a:ext cx="4046220" cy="411480"/>
+          </a:xfrm>
+          <a:prstGeom prst="rect">
+            <a:avLst/>
+          </a:prstGeom>
+          <a:solidFill>
+            <a:schemeClr val="accent1"/>
+          </a:solidFill>
+          <a:ln>
+            <a:noFill/>
+          </a:ln>
+          <a:effectLst/>
+        </p:spPr>
+        <p:style>
+          <a:lnRef idx="1">
+            <a:schemeClr val="accent1"/>
+          </a:lnRef>
+          <a:fillRef idx="3">
+            <a:schemeClr val="accent1"/>
+          </a:fillRef>
+          <a:effectRef idx="2">
+            <a:schemeClr val="accent1"/>
+          </a:effectRef>
+          <a:fontRef idx="minor">
+            <a:schemeClr val="lt1"/>
+          </a:fontRef>
+        </p:style>
+        <p:txBody>
+          <a:bodyPr rtlCol="0" anchor="ctr"/>
+          <a:lstStyle/>
+          <a:p/>
+        </p:txBody>
+      </p:sp>
+      <p:sp>
+        <p:nvSpPr>
+          <p:cNvPr id="25" name="macOS card heading"/>
+          <p:cNvSpPr txBox="1"/>
+          <p:nvPr/>
+        </p:nvSpPr>
+        <p:spPr>
+          <a:xfrm>
+            <a:off x="4777740" y="1783080"/>
+            <a:ext cx="3360420" cy="411480"/>
+          </a:xfrm>
+          <a:prstGeom prst="rect">
+            <a:avLst/>
+          </a:prstGeom>
+          <a:noFill/>
+        </p:spPr>
+        <p:txBody>
+          <a:bodyPr wrap="square" lIns="0" rIns="0" tIns="0" bIns="0" anchor="ctr">
+            <a:noAutofit/>
+          </a:bodyPr>
+          <a:lstStyle/>
+          <a:p>
+            <a:pPr algn="l">
+              <a:spcAft>
+                <a:spcPts val="400"/>
+              </a:spcAft>
+            </a:pPr>
+            <a:r>
+              <a:rPr sz="1500" b="1" lang="en-GB">
+                <a:solidFill>
+                  <a:schemeClr val="bg1"/>
+                </a:solidFill>
+                <a:latin typeface="+mj-lt"/>
+              </a:rPr>
+              <a:t>macOS</a:t>
+            </a:r>
+          </a:p>
+        </p:txBody>
+      </p:sp>
+      <p:pic>
+        <p:nvPicPr>
+          <p:cNvPr id="26" name="Icon macOS card" descr=""/>
+          <p:cNvPicPr>
+            <a:picLocks noChangeAspect="1"/>
+          </p:cNvPicPr>
+          <p:nvPr/>
+        </p:nvPicPr>
+        <p:blipFill>
+          <a:blip r:embed="rId4"/>
+          <a:stretch>
+            <a:fillRect/>
+          </a:stretch>
+        </p:blipFill>
+        <p:spPr>
+          <a:xfrm>
+            <a:off x="8247888" y="1833372"/>
+            <a:ext cx="310896" cy="310896"/>
+          </a:xfrm>
+          <a:prstGeom prst="rect">
+            <a:avLst/>
+          </a:prstGeom>
+        </p:spPr>
+      </p:pic>
+      <p:sp>
+        <p:nvSpPr>
+          <p:cNvPr id="27" name="macOS card text"/>
+          <p:cNvSpPr txBox="1"/>
+          <p:nvPr/>
+        </p:nvSpPr>
+        <p:spPr>
+          <a:xfrm>
+            <a:off x="4805172" y="2331720"/>
+            <a:ext cx="3744468" cy="1188720"/>
+          </a:xfrm>
+          <a:prstGeom prst="rect">
+            <a:avLst/>
+          </a:prstGeom>
+          <a:noFill/>
+        </p:spPr>
+        <p:txBody>
+          <a:bodyPr wrap="square" lIns="0" rIns="0" tIns="0" bIns="0" anchor="t">
+            <a:noAutofit/>
+          </a:bodyPr>
+          <a:lstStyle/>
           <a:p>
             <a:pPr algn="l" marL="182880" indent="-182880">
               <a:spcAft>
@@ -12558,265 +12809,22 @@
               <a:buChar char="▪"/>
             </a:pPr>
             <a:r>
+              <a:rPr sz="1300" b="1" lang="en-GB">
+                <a:solidFill>
+                  <a:schemeClr val="tx2"/>
+                </a:solidFill>
+              </a:rPr>
+              <a:t>Download: </a:t>
+            </a:r>
+            <a:r>
               <a:rPr sz="1300" b="0" lang="en-GB">
                 <a:solidFill>
                   <a:schemeClr val="tx1"/>
                 </a:solidFill>
               </a:rPr>
-              <a:t>Click Install Now</a:t>
-            </a:r>
-          </a:p>
-        </p:txBody>
-      </p:sp>
-      <p:sp>
-        <p:nvSpPr>
-          <p:cNvPr id="21" name="Windows check box"/>
-          <p:cNvSpPr/>
-          <p:nvPr/>
-        </p:nvSpPr>
-        <p:spPr>
-          <a:xfrm>
-            <a:off x="457200" y="3749040"/>
-            <a:ext cx="4046220" cy="566928"/>
-          </a:xfrm>
-          <a:prstGeom prst="rect">
-            <a:avLst/>
-          </a:prstGeom>
-          <a:solidFill>
-            <a:schemeClr val="tx2"/>
-          </a:solidFill>
-          <a:ln>
-            <a:noFill/>
-          </a:ln>
-          <a:effectLst/>
-        </p:spPr>
-        <p:style>
-          <a:lnRef idx="1">
-            <a:schemeClr val="accent1"/>
-          </a:lnRef>
-          <a:fillRef idx="3">
-            <a:schemeClr val="accent1"/>
-          </a:fillRef>
-          <a:effectRef idx="2">
-            <a:schemeClr val="accent1"/>
-          </a:effectRef>
-          <a:fontRef idx="minor">
-            <a:schemeClr val="lt1"/>
-          </a:fontRef>
-        </p:style>
-        <p:txBody>
-          <a:bodyPr rtlCol="0" anchor="ctr"/>
-          <a:lstStyle/>
-          <a:p/>
-        </p:txBody>
-      </p:sp>
-      <p:sp>
-        <p:nvSpPr>
-          <p:cNvPr id="22" name="Windows check code"/>
-          <p:cNvSpPr txBox="1"/>
-          <p:nvPr/>
-        </p:nvSpPr>
-        <p:spPr>
-          <a:xfrm>
-            <a:off x="594360" y="3840480"/>
-            <a:ext cx="3771900" cy="384048"/>
-          </a:xfrm>
-          <a:prstGeom prst="rect">
-            <a:avLst/>
-          </a:prstGeom>
-          <a:noFill/>
-        </p:spPr>
-        <p:txBody>
-          <a:bodyPr wrap="square" lIns="0" rIns="0" tIns="0" bIns="0" anchor="t">
-            <a:noAutofit/>
-          </a:bodyPr>
-          <a:lstStyle/>
-          <a:p>
-            <a:pPr algn="l">
-              <a:spcAft>
-                <a:spcPts val="0"/>
-              </a:spcAft>
-            </a:pPr>
-            <a:r>
-              <a:rPr sz="1150" b="0" lang="en-GB">
-                <a:solidFill>
-                  <a:schemeClr val="bg1"/>
-                </a:solidFill>
-                <a:latin typeface="Consolas"/>
-              </a:rPr>
-              <a:t>py -3.13 --version</a:t>
-            </a:r>
-          </a:p>
-        </p:txBody>
-      </p:sp>
-      <p:sp>
-        <p:nvSpPr>
-          <p:cNvPr id="23" name="macOS card body"/>
-          <p:cNvSpPr/>
-          <p:nvPr/>
-        </p:nvSpPr>
-        <p:spPr>
-          <a:xfrm>
-            <a:off x="4640580" y="2194560"/>
-            <a:ext cx="4046220" cy="1463040"/>
-          </a:xfrm>
-          <a:prstGeom prst="rect">
-            <a:avLst/>
-          </a:prstGeom>
-          <a:solidFill>
-            <a:schemeClr val="bg2"/>
-          </a:solidFill>
-          <a:ln>
-            <a:noFill/>
-          </a:ln>
-          <a:effectLst/>
-        </p:spPr>
-        <p:style>
-          <a:lnRef idx="1">
-            <a:schemeClr val="accent1"/>
-          </a:lnRef>
-          <a:fillRef idx="3">
-            <a:schemeClr val="accent1"/>
-          </a:fillRef>
-          <a:effectRef idx="2">
-            <a:schemeClr val="accent1"/>
-          </a:effectRef>
-          <a:fontRef idx="minor">
-            <a:schemeClr val="lt1"/>
-          </a:fontRef>
-        </p:style>
-        <p:txBody>
-          <a:bodyPr rtlCol="0" anchor="ctr"/>
-          <a:lstStyle/>
-          <a:p/>
-        </p:txBody>
-      </p:sp>
-      <p:sp>
-        <p:nvSpPr>
-          <p:cNvPr id="24" name="macOS card header"/>
-          <p:cNvSpPr/>
-          <p:nvPr/>
-        </p:nvSpPr>
-        <p:spPr>
-          <a:xfrm>
-            <a:off x="4640580" y="1783080"/>
-            <a:ext cx="4046220" cy="411480"/>
-          </a:xfrm>
-          <a:prstGeom prst="rect">
-            <a:avLst/>
-          </a:prstGeom>
-          <a:solidFill>
-            <a:schemeClr val="accent1"/>
-          </a:solidFill>
-          <a:ln>
-            <a:noFill/>
-          </a:ln>
-          <a:effectLst/>
-        </p:spPr>
-        <p:style>
-          <a:lnRef idx="1">
-            <a:schemeClr val="accent1"/>
-          </a:lnRef>
-          <a:fillRef idx="3">
-            <a:schemeClr val="accent1"/>
-          </a:fillRef>
-          <a:effectRef idx="2">
-            <a:schemeClr val="accent1"/>
-          </a:effectRef>
-          <a:fontRef idx="minor">
-            <a:schemeClr val="lt1"/>
-          </a:fontRef>
-        </p:style>
-        <p:txBody>
-          <a:bodyPr rtlCol="0" anchor="ctr"/>
-          <a:lstStyle/>
-          <a:p/>
-        </p:txBody>
-      </p:sp>
-      <p:sp>
-        <p:nvSpPr>
-          <p:cNvPr id="25" name="macOS card heading"/>
-          <p:cNvSpPr txBox="1"/>
-          <p:nvPr/>
-        </p:nvSpPr>
-        <p:spPr>
-          <a:xfrm>
-            <a:off x="4777740" y="1783080"/>
-            <a:ext cx="3360420" cy="411480"/>
-          </a:xfrm>
-          <a:prstGeom prst="rect">
-            <a:avLst/>
-          </a:prstGeom>
-          <a:noFill/>
-        </p:spPr>
-        <p:txBody>
-          <a:bodyPr wrap="square" lIns="0" rIns="0" tIns="0" bIns="0" anchor="ctr">
-            <a:noAutofit/>
-          </a:bodyPr>
-          <a:lstStyle/>
-          <a:p>
-            <a:pPr algn="l">
-              <a:spcAft>
-                <a:spcPts val="400"/>
-              </a:spcAft>
-            </a:pPr>
-            <a:r>
-              <a:rPr sz="1500" b="1" lang="en-GB">
-                <a:solidFill>
-                  <a:schemeClr val="bg1"/>
-                </a:solidFill>
-                <a:latin typeface="+mj-lt"/>
-              </a:rPr>
-              <a:t>macOS</a:t>
-            </a:r>
-          </a:p>
-        </p:txBody>
-      </p:sp>
-      <p:pic>
-        <p:nvPicPr>
-          <p:cNvPr id="26" name="Icon macOS card" descr=""/>
-          <p:cNvPicPr>
-            <a:picLocks noChangeAspect="1"/>
-          </p:cNvPicPr>
-          <p:nvPr/>
-        </p:nvPicPr>
-        <p:blipFill>
-          <a:blip r:embed="rId4"/>
-          <a:stretch>
-            <a:fillRect/>
-          </a:stretch>
-        </p:blipFill>
-        <p:spPr>
-          <a:xfrm>
-            <a:off x="8247888" y="1833372"/>
-            <a:ext cx="310896" cy="310896"/>
-          </a:xfrm>
-          <a:prstGeom prst="rect">
-            <a:avLst/>
-          </a:prstGeom>
-        </p:spPr>
-      </p:pic>
-      <p:sp>
-        <p:nvSpPr>
-          <p:cNvPr id="27" name="macOS card text"/>
-          <p:cNvSpPr txBox="1"/>
-          <p:nvPr/>
-        </p:nvSpPr>
-        <p:spPr>
-          <a:xfrm>
-            <a:off x="4805172" y="2331720"/>
-            <a:ext cx="3744468" cy="1188720"/>
-          </a:xfrm>
-          <a:prstGeom prst="rect">
-            <a:avLst/>
-          </a:prstGeom>
-          <a:noFill/>
-        </p:spPr>
-        <p:txBody>
-          <a:bodyPr wrap="square" lIns="0" rIns="0" tIns="0" bIns="0" anchor="t">
-            <a:noAutofit/>
-          </a:bodyPr>
-          <a:lstStyle/>
+              <a:t>macOS installer (Python 3.14.8)</a:t>
+            </a:r>
+          </a:p>
           <a:p>
             <a:pPr algn="l" marL="182880" indent="-182880">
               <a:spcAft>
@@ -12829,20 +12837,12 @@
               <a:buChar char="▪"/>
             </a:pPr>
             <a:r>
-              <a:rPr sz="1300" b="1" lang="en-GB">
-                <a:solidFill>
-                  <a:schemeClr val="tx2"/>
-                </a:solidFill>
-              </a:rPr>
-              <a:t>Download: </a:t>
-            </a:r>
-            <a:r>
               <a:rPr sz="1300" b="0" lang="en-GB">
                 <a:solidFill>
                   <a:schemeClr val="tx1"/>
                 </a:solidFill>
               </a:rPr>
-              <a:t>macOS 64-bit universal2 installer</a:t>
+              <a:t>Open the .pkg and click through</a:t>
             </a:r>
           </a:p>
           <a:p>
@@ -12862,47 +12862,7 @@
                   <a:schemeClr val="tx1"/>
                 </a:solidFill>
               </a:rPr>
-              <a:t>Open the downloaded .pkg</a:t>
-            </a:r>
-          </a:p>
-          <a:p>
-            <a:pPr algn="l" marL="182880" indent="-182880">
-              <a:spcAft>
-                <a:spcPts val="600"/>
-              </a:spcAft>
-              <a:buClr>
-                <a:schemeClr val="accent1"/>
-              </a:buClr>
-              <a:buFont typeface="Arial"/>
-              <a:buChar char="▪"/>
-            </a:pPr>
-            <a:r>
-              <a:rPr sz="1300" b="0" lang="en-GB">
-                <a:solidFill>
-                  <a:schemeClr val="tx1"/>
-                </a:solidFill>
-              </a:rPr>
-              <a:t>Click through the installer</a:t>
-            </a:r>
-          </a:p>
-          <a:p>
-            <a:pPr algn="l" marL="182880" indent="-182880">
-              <a:spcAft>
-                <a:spcPts val="600"/>
-              </a:spcAft>
-              <a:buClr>
-                <a:schemeClr val="accent1"/>
-              </a:buClr>
-              <a:buFont typeface="Arial"/>
-              <a:buChar char="▪"/>
-            </a:pPr>
-            <a:r>
-              <a:rPr sz="1300" b="0" lang="en-GB">
-                <a:solidFill>
-                  <a:schemeClr val="tx1"/>
-                </a:solidFill>
-              </a:rPr>
-              <a:t>Works on Apple silicon and Intel</a:t>
+              <a:t>Apple silicon and Intel</a:t>
             </a:r>
           </a:p>
         </p:txBody>
@@ -12983,7 +12943,7 @@
                 </a:solidFill>
                 <a:latin typeface="Consolas"/>
               </a:rPr>
-              <a:t>python3.13 --version</a:t>
+              <a:t>python3.14 --version</a:t>
             </a:r>
           </a:p>
         </p:txBody>
@@ -13087,7 +13047,7 @@
                   <a:schemeClr val="tx2"/>
                 </a:solidFill>
               </a:rPr>
-              <a:t>Both installers: </a:t>
+              <a:t>Both downloads: </a:t>
             </a:r>
             <a:r>
               <a:rPr sz="1300" b="0" lang="en-GB">
@@ -13096,7 +13056,7 @@
                 </a:solidFill>
                 <a:hlinkClick r:id="rId6"/>
               </a:rPr>
-              <a:t>python.org/downloads/release/python-31316</a:t>
+              <a:t>python.org/downloads</a:t>
             </a:r>
           </a:p>
           <a:p>
@@ -13111,7 +13071,7 @@
                   <a:schemeClr val="tx1"/>
                 </a:solidFill>
               </a:rPr>
-              <a:t>Not the yellow “Download Python 3.14” button: the course needs 3.13.</a:t>
+              <a:t>Or let Positron install it: Command Palette → Python: Install Python via uv</a:t>
             </a:r>
           </a:p>
         </p:txBody>
@@ -13416,7 +13376,7 @@
                   <a:schemeClr val="tx2"/>
                 </a:solidFill>
               </a:rPr>
-              <a:t>Packages</a:t>
+              <a:t>Project</a:t>
             </a:r>
           </a:p>
         </p:txBody>
@@ -14728,7 +14688,7 @@
                   <a:schemeClr val="tx2"/>
                 </a:solidFill>
               </a:rPr>
-              <a:t>Packages</a:t>
+              <a:t>Project</a:t>
             </a:r>
           </a:p>
         </p:txBody>
@@ -15441,7 +15401,7 @@
                   <a:schemeClr val="tx1"/>
                 </a:solidFill>
               </a:rPr>
-              <a:t>your own copy of the repository, linked to GitHub</a:t>
+              <a:t>your own copy of a repository; a public one needs no sign-in</a:t>
             </a:r>
           </a:p>
         </p:txBody>
@@ -15813,7 +15773,7 @@
                   <a:schemeClr val="tx1"/>
                 </a:solidFill>
               </a:rPr>
-              <a:t>File → Open Folder and choose the cloned folder.</a:t>
+              <a:t>File → Open Folder. The cloned folder is now your project.</a:t>
             </a:r>
           </a:p>
         </p:txBody>
@@ -15853,7 +15813,7 @@
           <a:p>
             <a:r>
               <a:rPr sz="1600" lang="en-GB"/>
-              <a:t>Step 4: install the course packages</a:t>
+              <a:t>Step 4: set up the project's Python</a:t>
             </a:r>
           </a:p>
         </p:txBody>
@@ -16118,7 +16078,7 @@
                   <a:schemeClr val="bg1"/>
                 </a:solidFill>
               </a:rPr>
-              <a:t>Packages</a:t>
+              <a:t>Project</a:t>
             </a:r>
           </a:p>
         </p:txBody>
@@ -16233,440 +16193,19 @@
       </p:sp>
       <p:sp>
         <p:nvSpPr>
-          <p:cNvPr id="16" name="Env code win caption bar"/>
+          <p:cNvPr id="16" name="Env steps step 1"/>
           <p:cNvSpPr/>
           <p:nvPr/>
         </p:nvSpPr>
         <p:spPr>
           <a:xfrm>
             <a:off x="457200" y="1783080"/>
-            <a:ext cx="5120640" cy="274320"/>
-          </a:xfrm>
-          <a:prstGeom prst="rect">
-            <a:avLst/>
-          </a:prstGeom>
-          <a:solidFill>
-            <a:schemeClr val="accent1"/>
-          </a:solidFill>
-          <a:ln>
-            <a:noFill/>
-          </a:ln>
-          <a:effectLst/>
-        </p:spPr>
-        <p:style>
-          <a:lnRef idx="1">
-            <a:schemeClr val="accent1"/>
-          </a:lnRef>
-          <a:fillRef idx="3">
-            <a:schemeClr val="accent1"/>
-          </a:fillRef>
-          <a:effectRef idx="2">
-            <a:schemeClr val="accent1"/>
-          </a:effectRef>
-          <a:fontRef idx="minor">
-            <a:schemeClr val="lt1"/>
-          </a:fontRef>
-        </p:style>
-        <p:txBody>
-          <a:bodyPr rtlCol="0" anchor="ctr"/>
-          <a:lstStyle/>
-          <a:p/>
-        </p:txBody>
-      </p:sp>
-      <p:sp>
-        <p:nvSpPr>
-          <p:cNvPr id="17" name="Env code win caption"/>
-          <p:cNvSpPr txBox="1"/>
-          <p:nvPr/>
-        </p:nvSpPr>
-        <p:spPr>
-          <a:xfrm>
-            <a:off x="566928" y="1783080"/>
-            <a:ext cx="4901184" cy="274320"/>
-          </a:xfrm>
-          <a:prstGeom prst="rect">
-            <a:avLst/>
-          </a:prstGeom>
-          <a:noFill/>
-        </p:spPr>
-        <p:txBody>
-          <a:bodyPr wrap="square" lIns="0" rIns="0" tIns="0" bIns="0" anchor="ctr">
-            <a:noAutofit/>
-          </a:bodyPr>
-          <a:lstStyle/>
-          <a:p>
-            <a:pPr algn="l">
-              <a:spcAft>
-                <a:spcPts val="400"/>
-              </a:spcAft>
-            </a:pPr>
-            <a:r>
-              <a:rPr sz="1100" b="1" lang="en-GB">
-                <a:solidFill>
-                  <a:schemeClr val="bg1"/>
-                </a:solidFill>
-              </a:rPr>
-              <a:t>Windows: Positron terminal (PowerShell)</a:t>
-            </a:r>
-          </a:p>
-        </p:txBody>
-      </p:sp>
-      <p:sp>
-        <p:nvSpPr>
-          <p:cNvPr id="18" name="Env code win box"/>
-          <p:cNvSpPr/>
-          <p:nvPr/>
-        </p:nvSpPr>
-        <p:spPr>
-          <a:xfrm>
-            <a:off x="457200" y="2057400"/>
-            <a:ext cx="5120640" cy="594360"/>
-          </a:xfrm>
-          <a:prstGeom prst="rect">
-            <a:avLst/>
-          </a:prstGeom>
-          <a:solidFill>
-            <a:schemeClr val="tx2"/>
-          </a:solidFill>
-          <a:ln>
-            <a:noFill/>
-          </a:ln>
-          <a:effectLst/>
-        </p:spPr>
-        <p:style>
-          <a:lnRef idx="1">
-            <a:schemeClr val="accent1"/>
-          </a:lnRef>
-          <a:fillRef idx="3">
-            <a:schemeClr val="accent1"/>
-          </a:fillRef>
-          <a:effectRef idx="2">
-            <a:schemeClr val="accent1"/>
-          </a:effectRef>
-          <a:fontRef idx="minor">
-            <a:schemeClr val="lt1"/>
-          </a:fontRef>
-        </p:style>
-        <p:txBody>
-          <a:bodyPr rtlCol="0" anchor="ctr"/>
-          <a:lstStyle/>
-          <a:p/>
-        </p:txBody>
-      </p:sp>
-      <p:sp>
-        <p:nvSpPr>
-          <p:cNvPr id="19" name="Env code win code"/>
-          <p:cNvSpPr txBox="1"/>
-          <p:nvPr/>
-        </p:nvSpPr>
-        <p:spPr>
-          <a:xfrm>
-            <a:off x="594360" y="2148840"/>
-            <a:ext cx="4846320" cy="411480"/>
-          </a:xfrm>
-          <a:prstGeom prst="rect">
-            <a:avLst/>
-          </a:prstGeom>
-          <a:noFill/>
-        </p:spPr>
-        <p:txBody>
-          <a:bodyPr wrap="square" lIns="0" rIns="0" tIns="0" bIns="0" anchor="t">
-            <a:noAutofit/>
-          </a:bodyPr>
-          <a:lstStyle/>
-          <a:p>
-            <a:pPr algn="l">
-              <a:spcAft>
-                <a:spcPts val="0"/>
-              </a:spcAft>
-            </a:pPr>
-            <a:r>
-              <a:rPr sz="1100" b="0" lang="en-GB">
-                <a:solidFill>
-                  <a:schemeClr val="bg1"/>
-                </a:solidFill>
-                <a:latin typeface="Consolas"/>
-              </a:rPr>
-              <a:t>py -3.13 -m venv .venv</a:t>
-            </a:r>
-          </a:p>
-          <a:p>
-            <a:pPr algn="l">
-              <a:spcAft>
-                <a:spcPts val="0"/>
-              </a:spcAft>
-            </a:pPr>
-            <a:r>
-              <a:rPr sz="1100" b="0" lang="en-GB">
-                <a:solidFill>
-                  <a:schemeClr val="bg1"/>
-                </a:solidFill>
-                <a:latin typeface="Consolas"/>
-              </a:rPr>
-              <a:t>.venv\Scripts\python -m pip install -r requirements.txt</a:t>
-            </a:r>
-          </a:p>
-        </p:txBody>
-      </p:sp>
-      <p:sp>
-        <p:nvSpPr>
-          <p:cNvPr id="20" name="Env code mac caption bar"/>
-          <p:cNvSpPr/>
-          <p:nvPr/>
-        </p:nvSpPr>
-        <p:spPr>
-          <a:xfrm>
-            <a:off x="457200" y="2743200"/>
-            <a:ext cx="5120640" cy="274320"/>
-          </a:xfrm>
-          <a:prstGeom prst="rect">
-            <a:avLst/>
-          </a:prstGeom>
-          <a:solidFill>
-            <a:schemeClr val="accent1"/>
-          </a:solidFill>
-          <a:ln>
-            <a:noFill/>
-          </a:ln>
-          <a:effectLst/>
-        </p:spPr>
-        <p:style>
-          <a:lnRef idx="1">
-            <a:schemeClr val="accent1"/>
-          </a:lnRef>
-          <a:fillRef idx="3">
-            <a:schemeClr val="accent1"/>
-          </a:fillRef>
-          <a:effectRef idx="2">
-            <a:schemeClr val="accent1"/>
-          </a:effectRef>
-          <a:fontRef idx="minor">
-            <a:schemeClr val="lt1"/>
-          </a:fontRef>
-        </p:style>
-        <p:txBody>
-          <a:bodyPr rtlCol="0" anchor="ctr"/>
-          <a:lstStyle/>
-          <a:p/>
-        </p:txBody>
-      </p:sp>
-      <p:sp>
-        <p:nvSpPr>
-          <p:cNvPr id="21" name="Env code mac caption"/>
-          <p:cNvSpPr txBox="1"/>
-          <p:nvPr/>
-        </p:nvSpPr>
-        <p:spPr>
-          <a:xfrm>
-            <a:off x="566928" y="2743200"/>
-            <a:ext cx="4901184" cy="274320"/>
-          </a:xfrm>
-          <a:prstGeom prst="rect">
-            <a:avLst/>
-          </a:prstGeom>
-          <a:noFill/>
-        </p:spPr>
-        <p:txBody>
-          <a:bodyPr wrap="square" lIns="0" rIns="0" tIns="0" bIns="0" anchor="ctr">
-            <a:noAutofit/>
-          </a:bodyPr>
-          <a:lstStyle/>
-          <a:p>
-            <a:pPr algn="l">
-              <a:spcAft>
-                <a:spcPts val="400"/>
-              </a:spcAft>
-            </a:pPr>
-            <a:r>
-              <a:rPr sz="1100" b="1" lang="en-GB">
-                <a:solidFill>
-                  <a:schemeClr val="bg1"/>
-                </a:solidFill>
-              </a:rPr>
-              <a:t>macOS: Positron terminal</a:t>
-            </a:r>
-          </a:p>
-        </p:txBody>
-      </p:sp>
-      <p:sp>
-        <p:nvSpPr>
-          <p:cNvPr id="22" name="Env code mac box"/>
-          <p:cNvSpPr/>
-          <p:nvPr/>
-        </p:nvSpPr>
-        <p:spPr>
-          <a:xfrm>
-            <a:off x="457200" y="3017520"/>
-            <a:ext cx="5120640" cy="594360"/>
-          </a:xfrm>
-          <a:prstGeom prst="rect">
-            <a:avLst/>
-          </a:prstGeom>
-          <a:solidFill>
-            <a:schemeClr val="tx2"/>
-          </a:solidFill>
-          <a:ln>
-            <a:noFill/>
-          </a:ln>
-          <a:effectLst/>
-        </p:spPr>
-        <p:style>
-          <a:lnRef idx="1">
-            <a:schemeClr val="accent1"/>
-          </a:lnRef>
-          <a:fillRef idx="3">
-            <a:schemeClr val="accent1"/>
-          </a:fillRef>
-          <a:effectRef idx="2">
-            <a:schemeClr val="accent1"/>
-          </a:effectRef>
-          <a:fontRef idx="minor">
-            <a:schemeClr val="lt1"/>
-          </a:fontRef>
-        </p:style>
-        <p:txBody>
-          <a:bodyPr rtlCol="0" anchor="ctr"/>
-          <a:lstStyle/>
-          <a:p/>
-        </p:txBody>
-      </p:sp>
-      <p:sp>
-        <p:nvSpPr>
-          <p:cNvPr id="23" name="Env code mac code"/>
-          <p:cNvSpPr txBox="1"/>
-          <p:nvPr/>
-        </p:nvSpPr>
-        <p:spPr>
-          <a:xfrm>
-            <a:off x="594360" y="3108960"/>
-            <a:ext cx="4846320" cy="411480"/>
-          </a:xfrm>
-          <a:prstGeom prst="rect">
-            <a:avLst/>
-          </a:prstGeom>
-          <a:noFill/>
-        </p:spPr>
-        <p:txBody>
-          <a:bodyPr wrap="square" lIns="0" rIns="0" tIns="0" bIns="0" anchor="t">
-            <a:noAutofit/>
-          </a:bodyPr>
-          <a:lstStyle/>
-          <a:p>
-            <a:pPr algn="l">
-              <a:spcAft>
-                <a:spcPts val="0"/>
-              </a:spcAft>
-            </a:pPr>
-            <a:r>
-              <a:rPr sz="1100" b="0" lang="en-GB">
-                <a:solidFill>
-                  <a:schemeClr val="bg1"/>
-                </a:solidFill>
-                <a:latin typeface="Consolas"/>
-              </a:rPr>
-              <a:t>python3.13 -m venv .venv</a:t>
-            </a:r>
-          </a:p>
-          <a:p>
-            <a:pPr algn="l">
-              <a:spcAft>
-                <a:spcPts val="0"/>
-              </a:spcAft>
-            </a:pPr>
-            <a:r>
-              <a:rPr sz="1100" b="0" lang="en-GB">
-                <a:solidFill>
-                  <a:schemeClr val="bg1"/>
-                </a:solidFill>
-                <a:latin typeface="Consolas"/>
-              </a:rPr>
-              <a:t>.venv/bin/python -m pip install -r requirements.txt</a:t>
-            </a:r>
-          </a:p>
-        </p:txBody>
-      </p:sp>
-      <p:sp>
-        <p:nvSpPr>
-          <p:cNvPr id="24" name="Env lines"/>
-          <p:cNvSpPr txBox="1"/>
-          <p:nvPr/>
-        </p:nvSpPr>
-        <p:spPr>
-          <a:xfrm>
-            <a:off x="457200" y="3703320"/>
-            <a:ext cx="5120640" cy="685800"/>
-          </a:xfrm>
-          <a:prstGeom prst="rect">
-            <a:avLst/>
-          </a:prstGeom>
-          <a:noFill/>
-        </p:spPr>
-        <p:txBody>
-          <a:bodyPr wrap="square" lIns="0" rIns="0" tIns="0" bIns="0" anchor="t">
-            <a:noAutofit/>
-          </a:bodyPr>
-          <a:lstStyle/>
-          <a:p>
-            <a:pPr algn="l">
-              <a:spcAft>
-                <a:spcPts val="200"/>
-              </a:spcAft>
-            </a:pPr>
-            <a:r>
-              <a:rPr sz="1200" b="1" lang="en-GB">
-                <a:solidFill>
-                  <a:schemeClr val="tx2"/>
-                </a:solidFill>
-              </a:rPr>
-              <a:t>Line 1 </a:t>
-            </a:r>
-            <a:r>
-              <a:rPr sz="1200" b="0" lang="en-GB">
-                <a:solidFill>
-                  <a:schemeClr val="tx1"/>
-                </a:solidFill>
-              </a:rPr>
-              <a:t>creates .venv, a private Python for this folder. </a:t>
-            </a:r>
-          </a:p>
-          <a:p>
-            <a:pPr algn="l">
-              <a:spcAft>
-                <a:spcPts val="200"/>
-              </a:spcAft>
-            </a:pPr>
-            <a:r>
-              <a:rPr sz="1200" b="1" lang="en-GB">
-                <a:solidFill>
-                  <a:schemeClr val="tx2"/>
-                </a:solidFill>
-              </a:rPr>
-              <a:t>Line 2 </a:t>
-            </a:r>
-            <a:r>
-              <a:rPr sz="1200" b="0" lang="en-GB">
-                <a:solidFill>
-                  <a:schemeClr val="tx1"/>
-                </a:solidFill>
-              </a:rPr>
-              <a:t>installs all course packages into it.</a:t>
-            </a:r>
-          </a:p>
-        </p:txBody>
-      </p:sp>
-      <p:sp>
-        <p:nvSpPr>
-          <p:cNvPr id="25" name="Interpreter panel"/>
-          <p:cNvSpPr/>
-          <p:nvPr/>
-        </p:nvSpPr>
-        <p:spPr>
-          <a:xfrm>
-            <a:off x="5760720" y="1783080"/>
-            <a:ext cx="2926080" cy="2606040"/>
-          </a:xfrm>
-          <a:prstGeom prst="rect">
-            <a:avLst/>
+            <a:ext cx="1733702" cy="548640"/>
+          </a:xfrm>
+          <a:prstGeom prst="homePlate">
+            <a:avLst>
+              <a:gd name="adj" fmla="val 28000"/>
+            </a:avLst>
           </a:prstGeom>
           <a:solidFill>
             <a:schemeClr val="bg2"/>
@@ -16691,6 +16230,310 @@
           </a:fontRef>
         </p:style>
         <p:txBody>
+          <a:bodyPr rtlCol="0" anchor="ctr" wrap="square" rIns="128016" tIns="18288" bIns="18288"/>
+          <a:lstStyle/>
+          <a:p>
+            <a:pPr algn="ctr"/>
+            <a:r>
+              <a:rPr sz="1200" b="1" lang="en-GB">
+                <a:solidFill>
+                  <a:schemeClr val="tx2"/>
+                </a:solidFill>
+              </a:rPr>
+              <a:t>Create</a:t>
+            </a:r>
+            <a:br/>
+            <a:r>
+              <a:rPr sz="1200" b="1" lang="en-GB">
+                <a:solidFill>
+                  <a:schemeClr val="tx2"/>
+                </a:solidFill>
+              </a:rPr>
+              <a:t>Environment</a:t>
+            </a:r>
+          </a:p>
+        </p:txBody>
+      </p:sp>
+      <p:sp>
+        <p:nvSpPr>
+          <p:cNvPr id="17" name="Env steps step 2"/>
+          <p:cNvSpPr/>
+          <p:nvPr/>
+        </p:nvSpPr>
+        <p:spPr>
+          <a:xfrm>
+            <a:off x="2081174" y="1783080"/>
+            <a:ext cx="1733702" cy="548640"/>
+          </a:xfrm>
+          <a:prstGeom prst="chevron">
+            <a:avLst>
+              <a:gd name="adj" fmla="val 28000"/>
+            </a:avLst>
+          </a:prstGeom>
+          <a:solidFill>
+            <a:schemeClr val="bg2"/>
+          </a:solidFill>
+          <a:ln>
+            <a:noFill/>
+          </a:ln>
+          <a:effectLst/>
+        </p:spPr>
+        <p:style>
+          <a:lnRef idx="1">
+            <a:schemeClr val="accent1"/>
+          </a:lnRef>
+          <a:fillRef idx="3">
+            <a:schemeClr val="accent1"/>
+          </a:fillRef>
+          <a:effectRef idx="2">
+            <a:schemeClr val="accent1"/>
+          </a:effectRef>
+          <a:fontRef idx="minor">
+            <a:schemeClr val="lt1"/>
+          </a:fontRef>
+        </p:style>
+        <p:txBody>
+          <a:bodyPr rtlCol="0" anchor="ctr" wrap="square" lIns="237744" rIns="128016" tIns="18288" bIns="18288"/>
+          <a:lstStyle/>
+          <a:p>
+            <a:pPr algn="ctr"/>
+            <a:r>
+              <a:rPr sz="1200" b="1" lang="en-GB">
+                <a:solidFill>
+                  <a:schemeClr val="tx2"/>
+                </a:solidFill>
+              </a:rPr>
+              <a:t>Venv</a:t>
+            </a:r>
+          </a:p>
+        </p:txBody>
+      </p:sp>
+      <p:sp>
+        <p:nvSpPr>
+          <p:cNvPr id="18" name="Env steps step 3"/>
+          <p:cNvSpPr/>
+          <p:nvPr/>
+        </p:nvSpPr>
+        <p:spPr>
+          <a:xfrm>
+            <a:off x="3705149" y="1783080"/>
+            <a:ext cx="1733702" cy="548640"/>
+          </a:xfrm>
+          <a:prstGeom prst="chevron">
+            <a:avLst>
+              <a:gd name="adj" fmla="val 28000"/>
+            </a:avLst>
+          </a:prstGeom>
+          <a:solidFill>
+            <a:schemeClr val="bg2"/>
+          </a:solidFill>
+          <a:ln>
+            <a:noFill/>
+          </a:ln>
+          <a:effectLst/>
+        </p:spPr>
+        <p:style>
+          <a:lnRef idx="1">
+            <a:schemeClr val="accent1"/>
+          </a:lnRef>
+          <a:fillRef idx="3">
+            <a:schemeClr val="accent1"/>
+          </a:fillRef>
+          <a:effectRef idx="2">
+            <a:schemeClr val="accent1"/>
+          </a:effectRef>
+          <a:fontRef idx="minor">
+            <a:schemeClr val="lt1"/>
+          </a:fontRef>
+        </p:style>
+        <p:txBody>
+          <a:bodyPr rtlCol="0" anchor="ctr" wrap="square" lIns="237744" rIns="128016" tIns="18288" bIns="18288"/>
+          <a:lstStyle/>
+          <a:p>
+            <a:pPr algn="ctr"/>
+            <a:r>
+              <a:rPr sz="1200" b="1" lang="en-GB">
+                <a:solidFill>
+                  <a:schemeClr val="tx2"/>
+                </a:solidFill>
+              </a:rPr>
+              <a:t>Python</a:t>
+            </a:r>
+            <a:br/>
+            <a:r>
+              <a:rPr sz="1200" b="1" lang="en-GB">
+                <a:solidFill>
+                  <a:schemeClr val="tx2"/>
+                </a:solidFill>
+              </a:rPr>
+              <a:t>3.14.8</a:t>
+            </a:r>
+          </a:p>
+        </p:txBody>
+      </p:sp>
+      <p:sp>
+        <p:nvSpPr>
+          <p:cNvPr id="19" name="Env steps step 4"/>
+          <p:cNvSpPr/>
+          <p:nvPr/>
+        </p:nvSpPr>
+        <p:spPr>
+          <a:xfrm>
+            <a:off x="5329123" y="1783080"/>
+            <a:ext cx="1733702" cy="548640"/>
+          </a:xfrm>
+          <a:prstGeom prst="chevron">
+            <a:avLst>
+              <a:gd name="adj" fmla="val 28000"/>
+            </a:avLst>
+          </a:prstGeom>
+          <a:solidFill>
+            <a:schemeClr val="bg2"/>
+          </a:solidFill>
+          <a:ln>
+            <a:noFill/>
+          </a:ln>
+          <a:effectLst/>
+        </p:spPr>
+        <p:style>
+          <a:lnRef idx="1">
+            <a:schemeClr val="accent1"/>
+          </a:lnRef>
+          <a:fillRef idx="3">
+            <a:schemeClr val="accent1"/>
+          </a:fillRef>
+          <a:effectRef idx="2">
+            <a:schemeClr val="accent1"/>
+          </a:effectRef>
+          <a:fontRef idx="minor">
+            <a:schemeClr val="lt1"/>
+          </a:fontRef>
+        </p:style>
+        <p:txBody>
+          <a:bodyPr rtlCol="0" anchor="ctr" wrap="square" lIns="237744" rIns="128016" tIns="18288" bIns="18288"/>
+          <a:lstStyle/>
+          <a:p>
+            <a:pPr algn="ctr"/>
+            <a:r>
+              <a:rPr sz="1200" b="1" lang="en-GB">
+                <a:solidFill>
+                  <a:schemeClr val="tx2"/>
+                </a:solidFill>
+              </a:rPr>
+              <a:t>Install</a:t>
+            </a:r>
+            <a:br/>
+            <a:r>
+              <a:rPr sz="1200" b="1" lang="en-GB">
+                <a:solidFill>
+                  <a:schemeClr val="tx2"/>
+                </a:solidFill>
+              </a:rPr>
+              <a:t>packages</a:t>
+            </a:r>
+          </a:p>
+        </p:txBody>
+      </p:sp>
+      <p:sp>
+        <p:nvSpPr>
+          <p:cNvPr id="20" name="Env steps step 5"/>
+          <p:cNvSpPr/>
+          <p:nvPr/>
+        </p:nvSpPr>
+        <p:spPr>
+          <a:xfrm>
+            <a:off x="6953098" y="1783080"/>
+            <a:ext cx="1733702" cy="548640"/>
+          </a:xfrm>
+          <a:prstGeom prst="chevron">
+            <a:avLst>
+              <a:gd name="adj" fmla="val 28000"/>
+            </a:avLst>
+          </a:prstGeom>
+          <a:solidFill>
+            <a:schemeClr val="bg2"/>
+          </a:solidFill>
+          <a:ln>
+            <a:noFill/>
+          </a:ln>
+          <a:effectLst/>
+        </p:spPr>
+        <p:style>
+          <a:lnRef idx="1">
+            <a:schemeClr val="accent1"/>
+          </a:lnRef>
+          <a:fillRef idx="3">
+            <a:schemeClr val="accent1"/>
+          </a:fillRef>
+          <a:effectRef idx="2">
+            <a:schemeClr val="accent1"/>
+          </a:effectRef>
+          <a:fontRef idx="minor">
+            <a:schemeClr val="lt1"/>
+          </a:fontRef>
+        </p:style>
+        <p:txBody>
+          <a:bodyPr rtlCol="0" anchor="ctr" wrap="square" lIns="237744" rIns="128016" tIns="18288" bIns="18288"/>
+          <a:lstStyle/>
+          <a:p>
+            <a:pPr algn="ctr"/>
+            <a:r>
+              <a:rPr sz="1200" b="1" lang="en-GB">
+                <a:solidFill>
+                  <a:schemeClr val="tx2"/>
+                </a:solidFill>
+              </a:rPr>
+              <a:t>.venv</a:t>
+            </a:r>
+            <a:br/>
+            <a:r>
+              <a:rPr sz="1200" b="1" lang="en-GB">
+                <a:solidFill>
+                  <a:schemeClr val="tx2"/>
+                </a:solidFill>
+              </a:rPr>
+              <a:t>selected</a:t>
+            </a:r>
+          </a:p>
+        </p:txBody>
+      </p:sp>
+      <p:sp>
+        <p:nvSpPr>
+          <p:cNvPr id="21" name="Env card body"/>
+          <p:cNvSpPr/>
+          <p:nvPr/>
+        </p:nvSpPr>
+        <p:spPr>
+          <a:xfrm>
+            <a:off x="457200" y="2926080"/>
+            <a:ext cx="3931920" cy="1463040"/>
+          </a:xfrm>
+          <a:prstGeom prst="rect">
+            <a:avLst/>
+          </a:prstGeom>
+          <a:solidFill>
+            <a:schemeClr val="bg2"/>
+          </a:solidFill>
+          <a:ln>
+            <a:noFill/>
+          </a:ln>
+          <a:effectLst/>
+        </p:spPr>
+        <p:style>
+          <a:lnRef idx="1">
+            <a:schemeClr val="accent1"/>
+          </a:lnRef>
+          <a:fillRef idx="3">
+            <a:schemeClr val="accent1"/>
+          </a:fillRef>
+          <a:effectRef idx="2">
+            <a:schemeClr val="accent1"/>
+          </a:effectRef>
+          <a:fontRef idx="minor">
+            <a:schemeClr val="lt1"/>
+          </a:fontRef>
+        </p:style>
+        <p:txBody>
           <a:bodyPr rtlCol="0" anchor="ctr"/>
           <a:lstStyle/>
           <a:p/>
@@ -16698,14 +16541,56 @@
       </p:sp>
       <p:sp>
         <p:nvSpPr>
-          <p:cNvPr id="26" name="Interpreter head"/>
+          <p:cNvPr id="22" name="Env card header"/>
+          <p:cNvSpPr/>
+          <p:nvPr/>
+        </p:nvSpPr>
+        <p:spPr>
+          <a:xfrm>
+            <a:off x="457200" y="2514600"/>
+            <a:ext cx="3931920" cy="411480"/>
+          </a:xfrm>
+          <a:prstGeom prst="rect">
+            <a:avLst/>
+          </a:prstGeom>
+          <a:solidFill>
+            <a:schemeClr val="accent1"/>
+          </a:solidFill>
+          <a:ln>
+            <a:noFill/>
+          </a:ln>
+          <a:effectLst/>
+        </p:spPr>
+        <p:style>
+          <a:lnRef idx="1">
+            <a:schemeClr val="accent1"/>
+          </a:lnRef>
+          <a:fillRef idx="3">
+            <a:schemeClr val="accent1"/>
+          </a:fillRef>
+          <a:effectRef idx="2">
+            <a:schemeClr val="accent1"/>
+          </a:effectRef>
+          <a:fontRef idx="minor">
+            <a:schemeClr val="lt1"/>
+          </a:fontRef>
+        </p:style>
+        <p:txBody>
+          <a:bodyPr rtlCol="0" anchor="ctr"/>
+          <a:lstStyle/>
+          <a:p/>
+        </p:txBody>
+      </p:sp>
+      <p:sp>
+        <p:nvSpPr>
+          <p:cNvPr id="23" name="Env card heading"/>
           <p:cNvSpPr txBox="1"/>
           <p:nvPr/>
         </p:nvSpPr>
         <p:spPr>
           <a:xfrm>
-            <a:off x="5897880" y="1874520"/>
-            <a:ext cx="2697480" cy="320040"/>
+            <a:off x="594360" y="2514600"/>
+            <a:ext cx="3246120" cy="411480"/>
           </a:xfrm>
           <a:prstGeom prst="rect">
             <a:avLst/>
@@ -16713,7 +16598,7 @@
           <a:noFill/>
         </p:spPr>
         <p:txBody>
-          <a:bodyPr wrap="square" lIns="0" rIns="0" tIns="0" bIns="0" anchor="t">
+          <a:bodyPr wrap="square" lIns="0" rIns="0" tIns="0" bIns="0" anchor="ctr">
             <a:noAutofit/>
           </a:bodyPr>
           <a:lstStyle/>
@@ -16724,26 +16609,249 @@
               </a:spcAft>
             </a:pPr>
             <a:r>
-              <a:rPr sz="1300" b="1" lang="en-GB">
+              <a:rPr sz="1500" b="1" lang="en-GB">
+                <a:solidFill>
+                  <a:schemeClr val="bg1"/>
+                </a:solidFill>
+                <a:latin typeface="+mj-lt"/>
+              </a:rPr>
+              <a:t>Positron then</a:t>
+            </a:r>
+          </a:p>
+        </p:txBody>
+      </p:sp>
+      <p:pic>
+        <p:nvPicPr>
+          <p:cNvPr id="24" name="Icon Env card" descr=""/>
+          <p:cNvPicPr>
+            <a:picLocks noChangeAspect="1"/>
+          </p:cNvPicPr>
+          <p:nvPr/>
+        </p:nvPicPr>
+        <p:blipFill>
+          <a:blip r:embed="rId3"/>
+          <a:stretch>
+            <a:fillRect/>
+          </a:stretch>
+        </p:blipFill>
+        <p:spPr>
+          <a:xfrm>
+            <a:off x="3950208" y="2564892"/>
+            <a:ext cx="310896" cy="310896"/>
+          </a:xfrm>
+          <a:prstGeom prst="rect">
+            <a:avLst/>
+          </a:prstGeom>
+        </p:spPr>
+      </p:pic>
+      <p:sp>
+        <p:nvSpPr>
+          <p:cNvPr id="25" name="Env card text"/>
+          <p:cNvSpPr txBox="1"/>
+          <p:nvPr/>
+        </p:nvSpPr>
+        <p:spPr>
+          <a:xfrm>
+            <a:off x="621792" y="3063240"/>
+            <a:ext cx="3630168" cy="1188720"/>
+          </a:xfrm>
+          <a:prstGeom prst="rect">
+            <a:avLst/>
+          </a:prstGeom>
+          <a:noFill/>
+        </p:spPr>
+        <p:txBody>
+          <a:bodyPr wrap="square" lIns="0" rIns="0" tIns="0" bIns="0" anchor="t">
+            <a:noAutofit/>
+          </a:bodyPr>
+          <a:lstStyle/>
+          <a:p>
+            <a:pPr algn="l" marL="182880" indent="-182880">
+              <a:spcAft>
+                <a:spcPts val="600"/>
+              </a:spcAft>
+              <a:buClr>
+                <a:schemeClr val="accent1"/>
+              </a:buClr>
+              <a:buFont typeface="Arial"/>
+              <a:buChar char="▪"/>
+            </a:pPr>
+            <a:r>
+              <a:rPr sz="1300" b="0" lang="en-GB">
+                <a:solidFill>
+                  <a:schemeClr val="tx1"/>
+                </a:solidFill>
+              </a:rPr>
+              <a:t>Start: Command Palette → Python: Create Environment</a:t>
+            </a:r>
+          </a:p>
+          <a:p>
+            <a:pPr algn="l" marL="182880" indent="-182880">
+              <a:spcAft>
+                <a:spcPts val="600"/>
+              </a:spcAft>
+              <a:buClr>
+                <a:schemeClr val="accent1"/>
+              </a:buClr>
+              <a:buFont typeface="Arial"/>
+              <a:buChar char="▪"/>
+            </a:pPr>
+            <a:r>
+              <a:rPr sz="1300" b="0" lang="en-GB">
+                <a:solidFill>
+                  <a:schemeClr val="tx1"/>
+                </a:solidFill>
+              </a:rPr>
+              <a:t>Creates .venv inside the project</a:t>
+            </a:r>
+          </a:p>
+          <a:p>
+            <a:pPr algn="l" marL="182880" indent="-182880">
+              <a:spcAft>
+                <a:spcPts val="600"/>
+              </a:spcAft>
+              <a:buClr>
+                <a:schemeClr val="accent1"/>
+              </a:buClr>
+              <a:buFont typeface="Arial"/>
+              <a:buChar char="▪"/>
+            </a:pPr>
+            <a:r>
+              <a:rPr sz="1300" b="0" lang="en-GB">
+                <a:solidFill>
+                  <a:schemeClr val="tx1"/>
+                </a:solidFill>
+              </a:rPr>
+              <a:t>Installs all course packages</a:t>
+            </a:r>
+          </a:p>
+          <a:p>
+            <a:pPr algn="l" marL="182880" indent="-182880">
+              <a:spcAft>
+                <a:spcPts val="600"/>
+              </a:spcAft>
+              <a:buClr>
+                <a:schemeClr val="accent1"/>
+              </a:buClr>
+              <a:buFont typeface="Arial"/>
+              <a:buChar char="▪"/>
+            </a:pPr>
+            <a:r>
+              <a:rPr sz="1300" b="0" lang="en-GB">
+                <a:solidFill>
+                  <a:schemeClr val="tx1"/>
+                </a:solidFill>
+              </a:rPr>
+              <a:t>Starts Python from .venv</a:t>
+            </a:r>
+          </a:p>
+        </p:txBody>
+      </p:sp>
+      <p:sp>
+        <p:nvSpPr>
+          <p:cNvPr id="26" name="Interpreter panel"/>
+          <p:cNvSpPr/>
+          <p:nvPr/>
+        </p:nvSpPr>
+        <p:spPr>
+          <a:xfrm>
+            <a:off x="4526280" y="2514600"/>
+            <a:ext cx="4160520" cy="868680"/>
+          </a:xfrm>
+          <a:prstGeom prst="rect">
+            <a:avLst/>
+          </a:prstGeom>
+          <a:solidFill>
+            <a:schemeClr val="bg2"/>
+          </a:solidFill>
+          <a:ln>
+            <a:noFill/>
+          </a:ln>
+          <a:effectLst/>
+        </p:spPr>
+        <p:style>
+          <a:lnRef idx="1">
+            <a:schemeClr val="accent1"/>
+          </a:lnRef>
+          <a:fillRef idx="3">
+            <a:schemeClr val="accent1"/>
+          </a:fillRef>
+          <a:effectRef idx="2">
+            <a:schemeClr val="accent1"/>
+          </a:effectRef>
+          <a:fontRef idx="minor">
+            <a:schemeClr val="lt1"/>
+          </a:fontRef>
+        </p:style>
+        <p:txBody>
+          <a:bodyPr rtlCol="0" anchor="ctr"/>
+          <a:lstStyle/>
+          <a:p/>
+        </p:txBody>
+      </p:sp>
+      <p:sp>
+        <p:nvSpPr>
+          <p:cNvPr id="27" name="Interpreter head"/>
+          <p:cNvSpPr txBox="1"/>
+          <p:nvPr/>
+        </p:nvSpPr>
+        <p:spPr>
+          <a:xfrm>
+            <a:off x="4663440" y="2514600"/>
+            <a:ext cx="1463040" cy="868680"/>
+          </a:xfrm>
+          <a:prstGeom prst="rect">
+            <a:avLst/>
+          </a:prstGeom>
+          <a:noFill/>
+        </p:spPr>
+        <p:txBody>
+          <a:bodyPr wrap="square" lIns="0" rIns="0" tIns="0" bIns="0" anchor="ctr">
+            <a:noAutofit/>
+          </a:bodyPr>
+          <a:lstStyle/>
+          <a:p>
+            <a:pPr algn="l">
+              <a:spcAft>
+                <a:spcPts val="0"/>
+              </a:spcAft>
+            </a:pPr>
+            <a:r>
+              <a:rPr sz="1200" b="1" lang="en-GB">
                 <a:solidFill>
                   <a:schemeClr val="tx2"/>
                 </a:solidFill>
               </a:rPr>
-              <a:t>Then: Interpreter picker</a:t>
-            </a:r>
-          </a:p>
-        </p:txBody>
-      </p:sp>
-      <p:sp>
-        <p:nvSpPr>
-          <p:cNvPr id="27" name="Interpreter pill"/>
+              <a:t>Interpreter picker</a:t>
+            </a:r>
+          </a:p>
+          <a:p>
+            <a:pPr algn="l">
+              <a:spcAft>
+                <a:spcPts val="0"/>
+              </a:spcAft>
+            </a:pPr>
+            <a:r>
+              <a:rPr sz="1100" b="0" lang="en-GB">
+                <a:solidFill>
+                  <a:schemeClr val="tx1"/>
+                </a:solidFill>
+              </a:rPr>
+              <a:t>top right</a:t>
+            </a:r>
+          </a:p>
+        </p:txBody>
+      </p:sp>
+      <p:sp>
+        <p:nvSpPr>
+          <p:cNvPr id="28" name="Interpreter pill"/>
           <p:cNvSpPr/>
           <p:nvPr/>
         </p:nvSpPr>
         <p:spPr>
           <a:xfrm>
-            <a:off x="5897880" y="2286000"/>
-            <a:ext cx="2651760" cy="384048"/>
+            <a:off x="6080760" y="2761488"/>
+            <a:ext cx="2468880" cy="384048"/>
           </a:xfrm>
           <a:prstGeom prst="roundRect">
             <a:avLst/>
@@ -16780,14 +16888,14 @@
       </p:sp>
       <p:sp>
         <p:nvSpPr>
-          <p:cNvPr id="28" name="Pill text"/>
+          <p:cNvPr id="29" name="Pill text"/>
           <p:cNvSpPr txBox="1"/>
           <p:nvPr/>
         </p:nvSpPr>
         <p:spPr>
           <a:xfrm>
-            <a:off x="5989320" y="2286000"/>
-            <a:ext cx="2514600" cy="384048"/>
+            <a:off x="6144768" y="2761488"/>
+            <a:ext cx="2377440" cy="384048"/>
           </a:xfrm>
           <a:prstGeom prst="rect">
             <a:avLst/>
@@ -16812,21 +16920,143 @@
                 </a:solidFill>
                 <a:latin typeface="Consolas"/>
               </a:rPr>
-              <a:t>Python 3.13.16 (.venv) ▾</a:t>
-            </a:r>
-          </a:p>
-        </p:txBody>
-      </p:sp>
-      <p:sp>
-        <p:nvSpPr>
-          <p:cNvPr id="29" name="Interpreter text"/>
+              <a:t>Python 3.14.8 (.venv) ▾</a:t>
+            </a:r>
+          </a:p>
+        </p:txBody>
+      </p:sp>
+      <p:sp>
+        <p:nvSpPr>
+          <p:cNvPr id="30" name="Env console caption bar"/>
+          <p:cNvSpPr/>
+          <p:nvPr/>
+        </p:nvSpPr>
+        <p:spPr>
+          <a:xfrm>
+            <a:off x="4526280" y="3520440"/>
+            <a:ext cx="4160520" cy="274320"/>
+          </a:xfrm>
+          <a:prstGeom prst="rect">
+            <a:avLst/>
+          </a:prstGeom>
+          <a:solidFill>
+            <a:schemeClr val="accent1"/>
+          </a:solidFill>
+          <a:ln>
+            <a:noFill/>
+          </a:ln>
+          <a:effectLst/>
+        </p:spPr>
+        <p:style>
+          <a:lnRef idx="1">
+            <a:schemeClr val="accent1"/>
+          </a:lnRef>
+          <a:fillRef idx="3">
+            <a:schemeClr val="accent1"/>
+          </a:fillRef>
+          <a:effectRef idx="2">
+            <a:schemeClr val="accent1"/>
+          </a:effectRef>
+          <a:fontRef idx="minor">
+            <a:schemeClr val="lt1"/>
+          </a:fontRef>
+        </p:style>
+        <p:txBody>
+          <a:bodyPr rtlCol="0" anchor="ctr"/>
+          <a:lstStyle/>
+          <a:p/>
+        </p:txBody>
+      </p:sp>
+      <p:sp>
+        <p:nvSpPr>
+          <p:cNvPr id="31" name="Env console caption"/>
           <p:cNvSpPr txBox="1"/>
           <p:nvPr/>
         </p:nvSpPr>
         <p:spPr>
           <a:xfrm>
-            <a:off x="5897880" y="2788920"/>
-            <a:ext cx="2697480" cy="1554480"/>
+            <a:off x="4636008" y="3520440"/>
+            <a:ext cx="3941064" cy="274320"/>
+          </a:xfrm>
+          <a:prstGeom prst="rect">
+            <a:avLst/>
+          </a:prstGeom>
+          <a:noFill/>
+        </p:spPr>
+        <p:txBody>
+          <a:bodyPr wrap="square" lIns="0" rIns="0" tIns="0" bIns="0" anchor="ctr">
+            <a:noAutofit/>
+          </a:bodyPr>
+          <a:lstStyle/>
+          <a:p>
+            <a:pPr algn="l">
+              <a:spcAft>
+                <a:spcPts val="400"/>
+              </a:spcAft>
+            </a:pPr>
+            <a:r>
+              <a:rPr sz="1100" b="1" lang="en-GB">
+                <a:solidFill>
+                  <a:schemeClr val="bg1"/>
+                </a:solidFill>
+              </a:rPr>
+              <a:t>Packages missing? Positron console</a:t>
+            </a:r>
+          </a:p>
+        </p:txBody>
+      </p:sp>
+      <p:sp>
+        <p:nvSpPr>
+          <p:cNvPr id="32" name="Env console box"/>
+          <p:cNvSpPr/>
+          <p:nvPr/>
+        </p:nvSpPr>
+        <p:spPr>
+          <a:xfrm>
+            <a:off x="4526280" y="3794760"/>
+            <a:ext cx="4160520" cy="594360"/>
+          </a:xfrm>
+          <a:prstGeom prst="rect">
+            <a:avLst/>
+          </a:prstGeom>
+          <a:solidFill>
+            <a:schemeClr val="tx2"/>
+          </a:solidFill>
+          <a:ln>
+            <a:noFill/>
+          </a:ln>
+          <a:effectLst/>
+        </p:spPr>
+        <p:style>
+          <a:lnRef idx="1">
+            <a:schemeClr val="accent1"/>
+          </a:lnRef>
+          <a:fillRef idx="3">
+            <a:schemeClr val="accent1"/>
+          </a:fillRef>
+          <a:effectRef idx="2">
+            <a:schemeClr val="accent1"/>
+          </a:effectRef>
+          <a:fontRef idx="minor">
+            <a:schemeClr val="lt1"/>
+          </a:fontRef>
+        </p:style>
+        <p:txBody>
+          <a:bodyPr rtlCol="0" anchor="ctr"/>
+          <a:lstStyle/>
+          <a:p/>
+        </p:txBody>
+      </p:sp>
+      <p:sp>
+        <p:nvSpPr>
+          <p:cNvPr id="33" name="Env console code"/>
+          <p:cNvSpPr txBox="1"/>
+          <p:nvPr/>
+        </p:nvSpPr>
+        <p:spPr>
+          <a:xfrm>
+            <a:off x="4663440" y="3886200"/>
+            <a:ext cx="3886200" cy="411480"/>
           </a:xfrm>
           <a:prstGeom prst="rect">
             <a:avLst/>
@@ -16839,70 +17069,26 @@
           </a:bodyPr>
           <a:lstStyle/>
           <a:p>
-            <a:pPr algn="l" marL="182880" indent="-182880">
+            <a:pPr algn="l">
               <a:spcAft>
-                <a:spcPts val="400"/>
+                <a:spcPts val="0"/>
               </a:spcAft>
-              <a:buClr>
-                <a:schemeClr val="accent1"/>
-              </a:buClr>
-              <a:buFont typeface="Arial"/>
-              <a:buChar char="▪"/>
             </a:pPr>
             <a:r>
-              <a:rPr sz="1200" b="0" lang="en-GB">
-                <a:solidFill>
-                  <a:schemeClr val="tx1"/>
-                </a:solidFill>
-              </a:rPr>
-              <a:t>Top right in Positron</a:t>
-            </a:r>
-          </a:p>
-          <a:p>
-            <a:pPr algn="l" marL="182880" indent="-182880">
-              <a:spcAft>
-                <a:spcPts val="400"/>
-              </a:spcAft>
-              <a:buClr>
-                <a:schemeClr val="accent1"/>
-              </a:buClr>
-              <a:buFont typeface="Arial"/>
-              <a:buChar char="▪"/>
-            </a:pPr>
-            <a:r>
-              <a:rPr sz="1200" b="0" lang="en-GB">
-                <a:solidFill>
-                  <a:schemeClr val="tx1"/>
-                </a:solidFill>
-              </a:rPr>
-              <a:t>Pick the Python in .venv</a:t>
-            </a:r>
-          </a:p>
-          <a:p>
-            <a:pPr algn="l" marL="182880" indent="-182880">
-              <a:spcAft>
-                <a:spcPts val="400"/>
-              </a:spcAft>
-              <a:buClr>
-                <a:schemeClr val="accent1"/>
-              </a:buClr>
-              <a:buFont typeface="Arial"/>
-              <a:buChar char="▪"/>
-            </a:pPr>
-            <a:r>
-              <a:rPr sz="1200" b="0" lang="en-GB">
-                <a:solidFill>
-                  <a:schemeClr val="tx1"/>
-                </a:solidFill>
-              </a:rPr>
-              <a:t>Positron remembers it for this folder</a:t>
-            </a:r>
-          </a:p>
-        </p:txBody>
-      </p:sp>
-      <p:sp>
-        <p:nvSpPr>
-          <p:cNvPr id="30" name="Create env box"/>
+              <a:rPr sz="1100" b="0" lang="en-GB">
+                <a:solidFill>
+                  <a:schemeClr val="bg1"/>
+                </a:solidFill>
+                <a:latin typeface="Consolas"/>
+              </a:rPr>
+              <a:t>%pip install -r requirements.txt</a:t>
+            </a:r>
+          </a:p>
+        </p:txBody>
+      </p:sp>
+      <p:sp>
+        <p:nvSpPr>
+          <p:cNvPr id="34" name="Once note box"/>
           <p:cNvSpPr/>
           <p:nvPr/>
         </p:nvSpPr>
@@ -16944,14 +17130,14 @@
       </p:sp>
       <p:pic>
         <p:nvPicPr>
-          <p:cNvPr id="31" name="Icon Create env" descr=""/>
+          <p:cNvPr id="35" name="Icon Once note" descr=""/>
           <p:cNvPicPr>
             <a:picLocks noChangeAspect="1"/>
           </p:cNvPicPr>
           <p:nvPr/>
         </p:nvPicPr>
         <p:blipFill>
-          <a:blip r:embed="rId3"/>
+          <a:blip r:embed="rId4"/>
           <a:stretch>
             <a:fillRect/>
           </a:stretch>
@@ -16968,7 +17154,7 @@
       </p:pic>
       <p:sp>
         <p:nvSpPr>
-          <p:cNvPr id="32" name="Create env text"/>
+          <p:cNvPr id="36" name="Once note text"/>
           <p:cNvSpPr txBox="1"/>
           <p:nvPr/>
         </p:nvSpPr>
@@ -16999,7 +17185,7 @@
                   <a:schemeClr val="tx2"/>
                 </a:solidFill>
               </a:rPr>
-              <a:t>No typing? </a:t>
+              <a:t>Once per project: </a:t>
             </a:r>
             <a:r>
               <a:rPr sz="1300" b="0" lang="en-GB">
@@ -17007,7 +17193,7 @@
                   <a:schemeClr val="tx1"/>
                 </a:solidFill>
               </a:rPr>
-              <a:t>Command Palette → Python: Create Environment → Venv → tick requirements.txt.</a:t>
+              <a:t>Positron remembers the .venv and starts it whenever you open the folder.</a:t>
             </a:r>
           </a:p>
         </p:txBody>
@@ -17312,7 +17498,7 @@
                   <a:schemeClr val="tx2"/>
                 </a:solidFill>
               </a:rPr>
-              <a:t>Packages</a:t>
+              <a:t>Project</a:t>
             </a:r>
           </a:p>
         </p:txBody>
@@ -17427,14 +17613,14 @@
       </p:sp>
       <p:sp>
         <p:nvSpPr>
-          <p:cNvPr id="16" name="Check command win caption bar"/>
+          <p:cNvPr id="16" name="Check command caption bar"/>
           <p:cNvSpPr/>
           <p:nvPr/>
         </p:nvSpPr>
         <p:spPr>
           <a:xfrm>
             <a:off x="457200" y="1783080"/>
-            <a:ext cx="4046220" cy="274320"/>
+            <a:ext cx="8229600" cy="274320"/>
           </a:xfrm>
           <a:prstGeom prst="rect">
             <a:avLst/>
@@ -17469,14 +17655,14 @@
       </p:sp>
       <p:sp>
         <p:nvSpPr>
-          <p:cNvPr id="17" name="Check command win caption"/>
+          <p:cNvPr id="17" name="Check command caption"/>
           <p:cNvSpPr txBox="1"/>
           <p:nvPr/>
         </p:nvSpPr>
         <p:spPr>
           <a:xfrm>
             <a:off x="566928" y="1783080"/>
-            <a:ext cx="3826764" cy="274320"/>
+            <a:ext cx="8010144" cy="274320"/>
           </a:xfrm>
           <a:prstGeom prst="rect">
             <a:avLst/>
@@ -17500,21 +17686,21 @@
                   <a:schemeClr val="bg1"/>
                 </a:solidFill>
               </a:rPr>
-              <a:t>Windows</a:t>
-            </a:r>
-          </a:p>
-        </p:txBody>
-      </p:sp>
-      <p:sp>
-        <p:nvSpPr>
-          <p:cNvPr id="18" name="Check command win box"/>
+              <a:t>Positron console (Windows and macOS)</a:t>
+            </a:r>
+          </a:p>
+        </p:txBody>
+      </p:sp>
+      <p:sp>
+        <p:nvSpPr>
+          <p:cNvPr id="18" name="Check command box"/>
           <p:cNvSpPr/>
           <p:nvPr/>
         </p:nvSpPr>
         <p:spPr>
           <a:xfrm>
             <a:off x="457200" y="2057400"/>
-            <a:ext cx="4046220" cy="411480"/>
+            <a:ext cx="8229600" cy="411480"/>
           </a:xfrm>
           <a:prstGeom prst="rect">
             <a:avLst/>
@@ -17549,14 +17735,14 @@
       </p:sp>
       <p:sp>
         <p:nvSpPr>
-          <p:cNvPr id="19" name="Check command win code"/>
+          <p:cNvPr id="19" name="Check command code"/>
           <p:cNvSpPr txBox="1"/>
           <p:nvPr/>
         </p:nvSpPr>
         <p:spPr>
           <a:xfrm>
             <a:off x="594360" y="2148840"/>
-            <a:ext cx="3771900" cy="228600"/>
+            <a:ext cx="7955280" cy="228600"/>
           </a:xfrm>
           <a:prstGeom prst="rect">
             <a:avLst/>
@@ -17581,21 +17767,21 @@
                 </a:solidFill>
                 <a:latin typeface="Consolas"/>
               </a:rPr>
-              <a:t>.venv\Scripts\python setup\check_setup.py</a:t>
-            </a:r>
-          </a:p>
-        </p:txBody>
-      </p:sp>
-      <p:sp>
-        <p:nvSpPr>
-          <p:cNvPr id="20" name="Check command mac caption bar"/>
+              <a:t>%run setup/check_setup.py</a:t>
+            </a:r>
+          </a:p>
+        </p:txBody>
+      </p:sp>
+      <p:sp>
+        <p:nvSpPr>
+          <p:cNvPr id="20" name="Check output caption bar"/>
           <p:cNvSpPr/>
           <p:nvPr/>
         </p:nvSpPr>
         <p:spPr>
           <a:xfrm>
-            <a:off x="4640580" y="1783080"/>
-            <a:ext cx="4046220" cy="274320"/>
+            <a:off x="457200" y="2606040"/>
+            <a:ext cx="5120640" cy="274320"/>
           </a:xfrm>
           <a:prstGeom prst="rect">
             <a:avLst/>
@@ -17630,14 +17816,14 @@
       </p:sp>
       <p:sp>
         <p:nvSpPr>
-          <p:cNvPr id="21" name="Check command mac caption"/>
+          <p:cNvPr id="21" name="Check output caption"/>
           <p:cNvSpPr txBox="1"/>
           <p:nvPr/>
         </p:nvSpPr>
         <p:spPr>
           <a:xfrm>
-            <a:off x="4750308" y="1783080"/>
-            <a:ext cx="3826764" cy="274320"/>
+            <a:off x="566928" y="2606040"/>
+            <a:ext cx="4901184" cy="274320"/>
           </a:xfrm>
           <a:prstGeom prst="rect">
             <a:avLst/>
@@ -17661,21 +17847,21 @@
                   <a:schemeClr val="bg1"/>
                 </a:solidFill>
               </a:rPr>
-              <a:t>macOS</a:t>
-            </a:r>
-          </a:p>
-        </p:txBody>
-      </p:sp>
-      <p:sp>
-        <p:nvSpPr>
-          <p:cNvPr id="22" name="Check command mac box"/>
+              <a:t>Example output (shortened)</a:t>
+            </a:r>
+          </a:p>
+        </p:txBody>
+      </p:sp>
+      <p:sp>
+        <p:nvSpPr>
+          <p:cNvPr id="22" name="Check output box"/>
           <p:cNvSpPr/>
           <p:nvPr/>
         </p:nvSpPr>
         <p:spPr>
           <a:xfrm>
-            <a:off x="4640580" y="2057400"/>
-            <a:ext cx="4046220" cy="411480"/>
+            <a:off x="457200" y="2880360"/>
+            <a:ext cx="5120640" cy="1645920"/>
           </a:xfrm>
           <a:prstGeom prst="rect">
             <a:avLst/>
@@ -17710,14 +17896,14 @@
       </p:sp>
       <p:sp>
         <p:nvSpPr>
-          <p:cNvPr id="23" name="Check command mac code"/>
+          <p:cNvPr id="23" name="Check output code"/>
           <p:cNvSpPr txBox="1"/>
           <p:nvPr/>
         </p:nvSpPr>
         <p:spPr>
           <a:xfrm>
-            <a:off x="4777740" y="2148840"/>
-            <a:ext cx="3771900" cy="228600"/>
+            <a:off x="594360" y="2971800"/>
+            <a:ext cx="4846320" cy="1463040"/>
           </a:xfrm>
           <a:prstGeom prst="rect">
             <a:avLst/>
@@ -17742,154 +17928,9 @@
                 </a:solidFill>
                 <a:latin typeface="Consolas"/>
               </a:rPr>
-              <a:t>.venv/bin/python setup/check_setup.py</a:t>
-            </a:r>
-          </a:p>
-        </p:txBody>
-      </p:sp>
-      <p:sp>
-        <p:nvSpPr>
-          <p:cNvPr id="24" name="Check output caption bar"/>
-          <p:cNvSpPr/>
-          <p:nvPr/>
-        </p:nvSpPr>
-        <p:spPr>
-          <a:xfrm>
-            <a:off x="457200" y="2606040"/>
-            <a:ext cx="5120640" cy="274320"/>
-          </a:xfrm>
-          <a:prstGeom prst="rect">
-            <a:avLst/>
-          </a:prstGeom>
-          <a:solidFill>
-            <a:schemeClr val="accent1"/>
-          </a:solidFill>
-          <a:ln>
-            <a:noFill/>
-          </a:ln>
-          <a:effectLst/>
-        </p:spPr>
-        <p:style>
-          <a:lnRef idx="1">
-            <a:schemeClr val="accent1"/>
-          </a:lnRef>
-          <a:fillRef idx="3">
-            <a:schemeClr val="accent1"/>
-          </a:fillRef>
-          <a:effectRef idx="2">
-            <a:schemeClr val="accent1"/>
-          </a:effectRef>
-          <a:fontRef idx="minor">
-            <a:schemeClr val="lt1"/>
-          </a:fontRef>
-        </p:style>
-        <p:txBody>
-          <a:bodyPr rtlCol="0" anchor="ctr"/>
-          <a:lstStyle/>
-          <a:p/>
-        </p:txBody>
-      </p:sp>
-      <p:sp>
-        <p:nvSpPr>
-          <p:cNvPr id="25" name="Check output caption"/>
-          <p:cNvSpPr txBox="1"/>
-          <p:nvPr/>
-        </p:nvSpPr>
-        <p:spPr>
-          <a:xfrm>
-            <a:off x="566928" y="2606040"/>
-            <a:ext cx="4901184" cy="274320"/>
-          </a:xfrm>
-          <a:prstGeom prst="rect">
-            <a:avLst/>
-          </a:prstGeom>
-          <a:noFill/>
-        </p:spPr>
-        <p:txBody>
-          <a:bodyPr wrap="square" lIns="0" rIns="0" tIns="0" bIns="0" anchor="ctr">
-            <a:noAutofit/>
-          </a:bodyPr>
-          <a:lstStyle/>
-          <a:p>
-            <a:pPr algn="l">
-              <a:spcAft>
-                <a:spcPts val="400"/>
-              </a:spcAft>
-            </a:pPr>
-            <a:r>
-              <a:rPr sz="1100" b="1" lang="en-GB">
-                <a:solidFill>
-                  <a:schemeClr val="bg1"/>
-                </a:solidFill>
-              </a:rPr>
-              <a:t>Example output (shortened)</a:t>
-            </a:r>
-          </a:p>
-        </p:txBody>
-      </p:sp>
-      <p:sp>
-        <p:nvSpPr>
-          <p:cNvPr id="26" name="Check output box"/>
-          <p:cNvSpPr/>
-          <p:nvPr/>
-        </p:nvSpPr>
-        <p:spPr>
-          <a:xfrm>
-            <a:off x="457200" y="2880360"/>
-            <a:ext cx="5120640" cy="1645920"/>
-          </a:xfrm>
-          <a:prstGeom prst="rect">
-            <a:avLst/>
-          </a:prstGeom>
-          <a:solidFill>
-            <a:schemeClr val="tx2"/>
-          </a:solidFill>
-          <a:ln>
-            <a:noFill/>
-          </a:ln>
-          <a:effectLst/>
-        </p:spPr>
-        <p:style>
-          <a:lnRef idx="1">
-            <a:schemeClr val="accent1"/>
-          </a:lnRef>
-          <a:fillRef idx="3">
-            <a:schemeClr val="accent1"/>
-          </a:fillRef>
-          <a:effectRef idx="2">
-            <a:schemeClr val="accent1"/>
-          </a:effectRef>
-          <a:fontRef idx="minor">
-            <a:schemeClr val="lt1"/>
-          </a:fontRef>
-        </p:style>
-        <p:txBody>
-          <a:bodyPr rtlCol="0" anchor="ctr"/>
-          <a:lstStyle/>
-          <a:p/>
-        </p:txBody>
-      </p:sp>
-      <p:sp>
-        <p:nvSpPr>
-          <p:cNvPr id="27" name="Check output code"/>
-          <p:cNvSpPr txBox="1"/>
-          <p:nvPr/>
-        </p:nvSpPr>
-        <p:spPr>
-          <a:xfrm>
-            <a:off x="594360" y="2971800"/>
-            <a:ext cx="4846320" cy="1463040"/>
-          </a:xfrm>
-          <a:prstGeom prst="rect">
-            <a:avLst/>
-          </a:prstGeom>
-          <a:noFill/>
-        </p:spPr>
-        <p:txBody>
-          <a:bodyPr wrap="square" lIns="0" rIns="0" tIns="0" bIns="0" anchor="t">
-            <a:noAutofit/>
-          </a:bodyPr>
-          <a:lstStyle/>
+              <a:t>Packages</a:t>
+            </a:r>
+          </a:p>
           <a:p>
             <a:pPr algn="l">
               <a:spcAft>
@@ -17903,7 +17944,7 @@
                 </a:solidFill>
                 <a:latin typeface="Consolas"/>
               </a:rPr>
-              <a:t>Packages</a:t>
+              <a:t>  [ok] polars           1.44.2     data wrangling</a:t>
             </a:r>
           </a:p>
           <a:p>
@@ -17919,7 +17960,7 @@
                 </a:solidFill>
                 <a:latin typeface="Consolas"/>
               </a:rPr>
-              <a:t>  [ok] polars           1.44.2     data wrangling</a:t>
+              <a:t>  [ok] plotnine         0.15.8     charts</a:t>
             </a:r>
           </a:p>
           <a:p>
@@ -17935,7 +17976,7 @@
                 </a:solidFill>
                 <a:latin typeface="Consolas"/>
               </a:rPr>
-              <a:t>  [ok] plotnine         0.15.8     charts</a:t>
+              <a:t>  [ok] great_tables     1.0.0      tables</a:t>
             </a:r>
           </a:p>
           <a:p>
@@ -17951,7 +17992,7 @@
                 </a:solidFill>
                 <a:latin typeface="Consolas"/>
               </a:rPr>
-              <a:t>  [ok] great_tables     1.0.0      tables</a:t>
+              <a:t>  [ok] statsmodels      0.15.0     regression</a:t>
             </a:r>
           </a:p>
           <a:p>
@@ -17967,7 +18008,7 @@
                 </a:solidFill>
                 <a:latin typeface="Consolas"/>
               </a:rPr>
-              <a:t>  [ok] statsmodels      0.15.0     regression</a:t>
+              <a:t>  ...</a:t>
             </a:r>
           </a:p>
           <a:p>
@@ -17983,22 +18024,6 @@
                 </a:solidFill>
                 <a:latin typeface="Consolas"/>
               </a:rPr>
-              <a:t>  ...</a:t>
-            </a:r>
-          </a:p>
-          <a:p>
-            <a:pPr algn="l">
-              <a:spcAft>
-                <a:spcPts val="0"/>
-              </a:spcAft>
-            </a:pPr>
-            <a:r>
-              <a:rPr sz="1100" b="0" lang="en-GB">
-                <a:solidFill>
-                  <a:schemeClr val="bg1"/>
-                </a:solidFill>
-                <a:latin typeface="Consolas"/>
-              </a:rPr>
               <a:t>ready</a:t>
             </a:r>
           </a:p>
@@ -18006,7 +18031,7 @@
       </p:sp>
       <p:sp>
         <p:nvSpPr>
-          <p:cNvPr id="28" name="Check card body"/>
+          <p:cNvPr id="24" name="Check card body"/>
           <p:cNvSpPr/>
           <p:nvPr/>
         </p:nvSpPr>
@@ -18048,7 +18073,7 @@
       </p:sp>
       <p:sp>
         <p:nvSpPr>
-          <p:cNvPr id="29" name="Check card header"/>
+          <p:cNvPr id="25" name="Check card header"/>
           <p:cNvSpPr/>
           <p:nvPr/>
         </p:nvSpPr>
@@ -18090,7 +18115,7 @@
       </p:sp>
       <p:sp>
         <p:nvSpPr>
-          <p:cNvPr id="30" name="Check card heading"/>
+          <p:cNvPr id="26" name="Check card heading"/>
           <p:cNvSpPr txBox="1"/>
           <p:nvPr/>
         </p:nvSpPr>
@@ -18129,7 +18154,7 @@
       </p:sp>
       <p:pic>
         <p:nvPicPr>
-          <p:cNvPr id="31" name="Icon Check card" descr=""/>
+          <p:cNvPr id="27" name="Icon Check card" descr=""/>
           <p:cNvPicPr>
             <a:picLocks noChangeAspect="1"/>
           </p:cNvPicPr>
@@ -18153,7 +18178,7 @@
       </p:pic>
       <p:sp>
         <p:nvSpPr>
-          <p:cNvPr id="32" name="Check card text"/>
+          <p:cNvPr id="28" name="Check card text"/>
           <p:cNvSpPr txBox="1"/>
           <p:nvPr/>
         </p:nvSpPr>
@@ -18236,7 +18261,7 @@
       </p:sp>
       <p:sp>
         <p:nvSpPr>
-          <p:cNvPr id="33" name="Run button box"/>
+          <p:cNvPr id="29" name="Run button box"/>
           <p:cNvSpPr/>
           <p:nvPr/>
         </p:nvSpPr>
@@ -18278,7 +18303,7 @@
       </p:sp>
       <p:pic>
         <p:nvPicPr>
-          <p:cNvPr id="34" name="Icon Run button" descr=""/>
+          <p:cNvPr id="30" name="Icon Run button" descr=""/>
           <p:cNvPicPr>
             <a:picLocks noChangeAspect="1"/>
           </p:cNvPicPr>
@@ -18302,7 +18327,7 @@
       </p:pic>
       <p:sp>
         <p:nvSpPr>
-          <p:cNvPr id="35" name="Run button text"/>
+          <p:cNvPr id="31" name="Run button text"/>
           <p:cNvSpPr txBox="1"/>
           <p:nvPr/>
         </p:nvSpPr>
@@ -18333,7 +18358,7 @@
                   <a:schemeClr val="tx2"/>
                 </a:solidFill>
               </a:rPr>
-              <a:t>No terminal? </a:t>
+              <a:t>Full test: </a:t>
             </a:r>
             <a:r>
               <a:rPr sz="1300" b="0" lang="en-GB">
@@ -18341,7 +18366,7 @@
                   <a:schemeClr val="tx1"/>
                 </a:solidFill>
               </a:rPr>
-              <a:t>Open setup/check_setup.py in Positron and press Run.</a:t>
+              <a:t>open setup/test_stack.qmd and press Preview (Ctrl/Cmd + Shift + K).</a:t>
             </a:r>
           </a:p>
         </p:txBody>
@@ -18646,7 +18671,7 @@
                   <a:schemeClr val="tx2"/>
                 </a:solidFill>
               </a:rPr>
-              <a:t>Packages</a:t>
+              <a:t>Project</a:t>
             </a:r>
           </a:p>
         </p:txBody>
@@ -19900,7 +19925,7 @@
                 </a:solidFill>
                 <a:latin typeface="Consolas"/>
               </a:rPr>
-              <a:t>Python 3.13.16 (.venv) ▾</a:t>
+              <a:t>Python 3.14.8 (.venv) ▾</a:t>
             </a:r>
           </a:p>
         </p:txBody>
@@ -23330,7 +23355,7 @@
                   <a:schemeClr val="tx2"/>
                 </a:solidFill>
               </a:rPr>
-              <a:t>Packages</a:t>
+              <a:t>Project</a:t>
             </a:r>
           </a:p>
         </p:txBody>
@@ -24592,7 +24617,7 @@
                   <a:schemeClr val="tx2"/>
                 </a:solidFill>
               </a:rPr>
-              <a:t>Python 3.13</a:t>
+              <a:t>Python 3.14</a:t>
             </a:r>
             <a:br/>
             <a:r>
@@ -26302,7 +26327,7 @@
                   <a:schemeClr val="tx1"/>
                 </a:solidFill>
               </a:rPr>
-              <a:t>Create .venv from requirements.txt (Step 4)</a:t>
+              <a:t>Create Environment from requirements.txt (Step 4)</a:t>
             </a:r>
           </a:p>
           <a:p>
@@ -29992,7 +30017,7 @@
         </p:nvSpPr>
         <p:spPr>
           <a:xfrm>
-            <a:off x="457200" y="1234440"/>
+            <a:off x="457200" y="1965960"/>
             <a:ext cx="8229600" cy="274320"/>
           </a:xfrm>
           <a:prstGeom prst="rect">
@@ -30034,7 +30059,7 @@
         </p:nvSpPr>
         <p:spPr>
           <a:xfrm>
-            <a:off x="566928" y="1234440"/>
+            <a:off x="566928" y="1965960"/>
             <a:ext cx="8010144" cy="274320"/>
           </a:xfrm>
           <a:prstGeom prst="rect">
@@ -30059,7 +30084,7 @@
                   <a:schemeClr val="bg1"/>
                 </a:solidFill>
               </a:rPr>
-              <a:t>1  Windows: Positron terminal</a:t>
+              <a:t>2  Windows: Positron terminal</a:t>
             </a:r>
           </a:p>
         </p:txBody>
@@ -30072,7 +30097,7 @@
         </p:nvSpPr>
         <p:spPr>
           <a:xfrm>
-            <a:off x="457200" y="1508760"/>
+            <a:off x="457200" y="2240280"/>
             <a:ext cx="8229600" cy="594360"/>
           </a:xfrm>
           <a:prstGeom prst="rect">
@@ -30114,7 +30139,7 @@
         </p:nvSpPr>
         <p:spPr>
           <a:xfrm>
-            <a:off x="594360" y="1600200"/>
+            <a:off x="594360" y="2331720"/>
             <a:ext cx="7955280" cy="411480"/>
           </a:xfrm>
           <a:prstGeom prst="rect">
@@ -30169,7 +30194,7 @@
         </p:nvSpPr>
         <p:spPr>
           <a:xfrm>
-            <a:off x="457200" y="2212848"/>
+            <a:off x="457200" y="2944368"/>
             <a:ext cx="8229600" cy="274320"/>
           </a:xfrm>
           <a:prstGeom prst="rect">
@@ -30211,7 +30236,7 @@
         </p:nvSpPr>
         <p:spPr>
           <a:xfrm>
-            <a:off x="566928" y="2212848"/>
+            <a:off x="566928" y="2944368"/>
             <a:ext cx="8010144" cy="274320"/>
           </a:xfrm>
           <a:prstGeom prst="rect">
@@ -30236,7 +30261,7 @@
                   <a:schemeClr val="bg1"/>
                 </a:solidFill>
               </a:rPr>
-              <a:t>2  macOS: Positron terminal</a:t>
+              <a:t>3  macOS: Positron terminal</a:t>
             </a:r>
           </a:p>
         </p:txBody>
@@ -30249,7 +30274,7 @@
         </p:nvSpPr>
         <p:spPr>
           <a:xfrm>
-            <a:off x="457200" y="2487168"/>
+            <a:off x="457200" y="3218688"/>
             <a:ext cx="8229600" cy="594360"/>
           </a:xfrm>
           <a:prstGeom prst="rect">
@@ -30291,7 +30316,7 @@
         </p:nvSpPr>
         <p:spPr>
           <a:xfrm>
-            <a:off x="594360" y="2578608"/>
+            <a:off x="594360" y="3310128"/>
             <a:ext cx="7955280" cy="411480"/>
           </a:xfrm>
           <a:prstGeom prst="rect">
@@ -30346,7 +30371,7 @@
         </p:nvSpPr>
         <p:spPr>
           <a:xfrm>
-            <a:off x="457200" y="3191256"/>
+            <a:off x="457200" y="1234440"/>
             <a:ext cx="8229600" cy="274320"/>
           </a:xfrm>
           <a:prstGeom prst="rect">
@@ -30388,7 +30413,7 @@
         </p:nvSpPr>
         <p:spPr>
           <a:xfrm>
-            <a:off x="566928" y="3191256"/>
+            <a:off x="566928" y="1234440"/>
             <a:ext cx="8010144" cy="274320"/>
           </a:xfrm>
           <a:prstGeom prst="rect">
@@ -30413,7 +30438,7 @@
                   <a:schemeClr val="bg1"/>
                 </a:solidFill>
               </a:rPr>
-              <a:t>3  Windows and macOS: Positron console</a:t>
+              <a:t>1  Windows and macOS: Positron console (easiest)</a:t>
             </a:r>
           </a:p>
         </p:txBody>
@@ -30426,7 +30451,7 @@
         </p:nvSpPr>
         <p:spPr>
           <a:xfrm>
-            <a:off x="457200" y="3465576"/>
+            <a:off x="457200" y="1508760"/>
             <a:ext cx="8229600" cy="365760"/>
           </a:xfrm>
           <a:prstGeom prst="rect">
@@ -30468,7 +30493,7 @@
         </p:nvSpPr>
         <p:spPr>
           <a:xfrm>
-            <a:off x="594360" y="3557016"/>
+            <a:off x="594360" y="1600200"/>
             <a:ext cx="7955280" cy="182880"/>
           </a:xfrm>
           <a:prstGeom prst="rect">
@@ -31035,7 +31060,7 @@
                   <a:schemeClr val="tx1"/>
                 </a:solidFill>
               </a:rPr>
-              <a:t>     Python 3.13.16 (.venv)</a:t>
+              <a:t>     Python 3.14.8 (.venv)</a:t>
             </a:r>
           </a:p>
         </p:txBody>
@@ -38734,7 +38759,7 @@
                     <a:p>
                       <a:r>
                         <a:rPr sz="1300" lang="en-GB"/>
-                        <a:t>Reinstall Python 3.13 with “Add python.exe to PATH” ticked</a:t>
+                        <a:t>Reinstall the Python install manager, then run py install 3.14</a:t>
                       </a:r>
                     </a:p>
                   </a:txBody>
@@ -38762,7 +38787,7 @@
                     <a:p>
                       <a:r>
                         <a:rPr sz="1300" lang="en-GB"/>
-                        <a:t>Open the course folder, not a single file; then pick Python 3.13.16 (.venv)</a:t>
+                        <a:t>Open the course folder, not a single file; then pick Python 3.14.8 (.venv)</a:t>
                       </a:r>
                     </a:p>
                   </a:txBody>
@@ -38818,7 +38843,7 @@
                     <a:p>
                       <a:r>
                         <a:rPr sz="1300" lang="en-GB"/>
-                        <a:t>You used the system Python: use the .venv/bin/python commands</a:t>
+                        <a:t>You used the system Python: select the project's .venv first</a:t>
                       </a:r>
                     </a:p>
                   </a:txBody>
@@ -39690,7 +39715,7 @@
                   <a:schemeClr val="tx1"/>
                 </a:solidFill>
               </a:rPr>
-              <a:t>Python 3.13, Positron, Quarto, GitHub Desktop</a:t>
+              <a:t>Python 3.14, Positron, Quarto, GitHub Desktop</a:t>
             </a:r>
           </a:p>
         </p:txBody>
@@ -39936,7 +39961,7 @@
                   <a:schemeClr val="tx1"/>
                 </a:solidFill>
               </a:rPr>
-              <a:t>Check script prints “ready”</a:t>
+              <a:t>“ready” and the test report renders</a:t>
             </a:r>
           </a:p>
         </p:txBody>
@@ -40502,7 +40527,7 @@
                   <a:schemeClr val="tx2"/>
                 </a:solidFill>
               </a:rPr>
-              <a:t>Packages</a:t>
+              <a:t>Project</a:t>
             </a:r>
           </a:p>
         </p:txBody>
@@ -41500,7 +41525,7 @@
                   <a:schemeClr val="tx2"/>
                 </a:solidFill>
               </a:rPr>
-              <a:t>Packages</a:t>
+              <a:t>Project</a:t>
             </a:r>
           </a:p>
         </p:txBody>
@@ -42864,7 +42889,7 @@
                   <a:schemeClr val="tx2"/>
                 </a:solidFill>
               </a:rPr>
-              <a:t>Packages</a:t>
+              <a:t>Project</a:t>
             </a:r>
           </a:p>
         </p:txBody>
@@ -44182,7 +44207,7 @@
                   <a:schemeClr val="tx2"/>
                 </a:solidFill>
               </a:rPr>
-              <a:t>Packages</a:t>
+              <a:t>Project</a:t>
             </a:r>
           </a:p>
         </p:txBody>

</xml_diff>

<commit_message>
Set-up deck, guide and Session 1 lab: push to a group repository is optional
Clone and pull the course repository stay required; students work in their
own folder. Combining group work through a private GitHub repository is one
of two ways; only the files uploaded to Canvas are assessed.

Co-Authored-By: Claude Opus 5.5 <noreply@anthropic.com>
Claude-Session: https://claude.ai/code/session_01TbrdxHn7W6FVXXnpqzNytd
</commit_message>
<xml_diff>
--- a/slides/01a_setup-and-registration_WT26-27.pptx
+++ b/slides/01a_setup-and-registration_WT26-27.pptx
@@ -2177,7 +2177,7 @@
           <a:lstStyle/>
           <a:p>
             <a:r>
-              <a:t>Pull before you start, commit small steps, push when you stop. A merge conflict happens when two people change the same lines; GitHub Desktop lists the files, and Posit Assistant can explain the markers.</a:t>
+              <a:t>Required: pull the course repository before every session and work in your own folder, not inside the course repository, so your edits never clash with our updates. Optional: a group repository with commit and push. A merge conflict happens only there, when two people change the same lines; GitHub Desktop lists the files, and Posit Assistant can explain the markers.</a:t>
             </a:r>
           </a:p>
         </p:txBody>
@@ -2247,7 +2247,7 @@
           <a:lstStyle/>
           <a:p>
             <a:r>
-              <a:t>GitHub in the browser is where the repository is created and the group is invited; GitHub Desktop keeps each laptop's copy in sync; Positron is where the work happens.</a:t>
+              <a:t>Required for everyone: pull the course repository, copy the case material into the group's own project folder and create the environment there. Groups then choose how to combine their work: the simple way (one member keeps report.qmd, the others send code chunks and text) or a private GitHub repository published from GitHub Desktop. Only the two files uploaded to Canvas are assessed.</a:t>
             </a:r>
           </a:p>
         </p:txBody>
@@ -14760,7 +14760,7 @@
                   <a:schemeClr val="tx1"/>
                 </a:solidFill>
               </a:rPr>
-              <a:t>Clone, pull and push with clicks</a:t>
+              <a:t>Clone and pull with clicks; push if your group shares a repository</a:t>
             </a:r>
           </a:p>
           <a:p>
@@ -16229,7 +16229,7 @@
                   <a:schemeClr val="tx1"/>
                 </a:solidFill>
               </a:rPr>
-              <a:t>save and upload your changes (group repository)</a:t>
+              <a:t>optional: share work in a group repository</a:t>
             </a:r>
           </a:p>
         </p:txBody>
@@ -29395,7 +29395,7 @@
           <a:p>
             <a:r>
               <a:rPr lang="en-GB"/>
-              <a:t>Part 4 of 6 · the window, the everyday workflow, your group project</a:t>
+              <a:t>Part 4 of 6 · the window, the everyday workflow, working as a group</a:t>
             </a:r>
           </a:p>
         </p:txBody>
@@ -31891,7 +31891,7 @@
                   <a:schemeClr val="tx1"/>
                 </a:solidFill>
               </a:rPr>
-              <a:t>you only pull. Your own work goes in your files or in your group repository.</a:t>
+              <a:t>you only pull. Work in your own folder; a group repository is optional.</a:t>
             </a:r>
           </a:p>
         </p:txBody>
@@ -31994,7 +31994,7 @@
         <p:spPr>
           <a:xfrm>
             <a:off x="457200" y="1234440"/>
-            <a:ext cx="1733702" cy="548640"/>
+            <a:ext cx="2139696" cy="548640"/>
           </a:xfrm>
           <a:prstGeom prst="homePlate">
             <a:avLst>
@@ -32056,8 +32056,8 @@
         </p:nvSpPr>
         <p:spPr>
           <a:xfrm>
-            <a:off x="2081174" y="1234440"/>
-            <a:ext cx="1733702" cy="548640"/>
+            <a:off x="2487168" y="1234440"/>
+            <a:ext cx="2139696" cy="548640"/>
           </a:xfrm>
           <a:prstGeom prst="chevron">
             <a:avLst>
@@ -32097,7 +32097,7 @@
                   <a:schemeClr val="tx2"/>
                 </a:solidFill>
               </a:rPr>
-              <a:t>Work in</a:t>
+              <a:t>Copy files into</a:t>
             </a:r>
             <a:br/>
             <a:r>
@@ -32106,7 +32106,7 @@
                   <a:schemeClr val="tx2"/>
                 </a:solidFill>
               </a:rPr>
-              <a:t>Positron</a:t>
+              <a:t>your own folder</a:t>
             </a:r>
           </a:p>
         </p:txBody>
@@ -32119,8 +32119,8 @@
         </p:nvSpPr>
         <p:spPr>
           <a:xfrm>
-            <a:off x="3705149" y="1234440"/>
-            <a:ext cx="1733702" cy="548640"/>
+            <a:off x="4517136" y="1234440"/>
+            <a:ext cx="2139696" cy="548640"/>
           </a:xfrm>
           <a:prstGeom prst="chevron">
             <a:avLst>
@@ -32160,7 +32160,7 @@
                   <a:schemeClr val="tx2"/>
                 </a:solidFill>
               </a:rPr>
-              <a:t>Review</a:t>
+              <a:t>Work in</a:t>
             </a:r>
             <a:br/>
             <a:r>
@@ -32169,7 +32169,7 @@
                   <a:schemeClr val="tx2"/>
                 </a:solidFill>
               </a:rPr>
-              <a:t>Changes</a:t>
+              <a:t>Positron</a:t>
             </a:r>
           </a:p>
         </p:txBody>
@@ -32182,8 +32182,8 @@
         </p:nvSpPr>
         <p:spPr>
           <a:xfrm>
-            <a:off x="5329123" y="1234440"/>
-            <a:ext cx="1733702" cy="548640"/>
+            <a:off x="6547104" y="1234440"/>
+            <a:ext cx="2139696" cy="548640"/>
           </a:xfrm>
           <a:prstGeom prst="chevron">
             <a:avLst>
@@ -32223,7 +32223,7 @@
                   <a:schemeClr val="tx2"/>
                 </a:solidFill>
               </a:rPr>
-              <a:t>Summary +</a:t>
+              <a:t>Optional:</a:t>
             </a:r>
             <a:br/>
             <a:r>
@@ -32232,26 +32232,24 @@
                   <a:schemeClr val="tx2"/>
                 </a:solidFill>
               </a:rPr>
-              <a:t>Commit</a:t>
-            </a:r>
-          </a:p>
-        </p:txBody>
-      </p:sp>
-      <p:sp>
-        <p:nvSpPr>
-          <p:cNvPr id="14" name="Flow steps step 5"/>
+              <a:t>commit, push</a:t>
+            </a:r>
+          </a:p>
+        </p:txBody>
+      </p:sp>
+      <p:sp>
+        <p:nvSpPr>
+          <p:cNvPr id="14" name="Flow card 1 body"/>
           <p:cNvSpPr/>
           <p:nvPr/>
         </p:nvSpPr>
         <p:spPr>
           <a:xfrm>
-            <a:off x="6953098" y="1234440"/>
-            <a:ext cx="1733702" cy="548640"/>
-          </a:xfrm>
-          <a:prstGeom prst="chevron">
-            <a:avLst>
-              <a:gd name="adj" fmla="val 28000"/>
-            </a:avLst>
+            <a:off x="457200" y="2377440"/>
+            <a:ext cx="2651760" cy="1828800"/>
+          </a:xfrm>
+          <a:prstGeom prst="rect">
+            <a:avLst/>
           </a:prstGeom>
           <a:solidFill>
             <a:schemeClr val="bg2"/>
@@ -32276,46 +32274,27 @@
           </a:fontRef>
         </p:style>
         <p:txBody>
-          <a:bodyPr rtlCol="0" anchor="ctr" wrap="square" lIns="237744" rIns="128016" tIns="18288" bIns="18288"/>
-          <a:lstStyle/>
-          <a:p>
-            <a:pPr algn="ctr"/>
-            <a:r>
-              <a:rPr sz="1200" b="1" lang="en-GB">
-                <a:solidFill>
-                  <a:schemeClr val="tx2"/>
-                </a:solidFill>
-              </a:rPr>
-              <a:t>Push</a:t>
-            </a:r>
-            <a:br/>
-            <a:r>
-              <a:rPr sz="1200" b="1" lang="en-GB">
-                <a:solidFill>
-                  <a:schemeClr val="tx2"/>
-                </a:solidFill>
-              </a:rPr>
-              <a:t>origin</a:t>
-            </a:r>
-          </a:p>
-        </p:txBody>
-      </p:sp>
-      <p:sp>
-        <p:nvSpPr>
-          <p:cNvPr id="15" name="Flow card 1 body"/>
+          <a:bodyPr rtlCol="0" anchor="ctr"/>
+          <a:lstStyle/>
+          <a:p/>
+        </p:txBody>
+      </p:sp>
+      <p:sp>
+        <p:nvSpPr>
+          <p:cNvPr id="15" name="Flow card 1 header"/>
           <p:cNvSpPr/>
           <p:nvPr/>
         </p:nvSpPr>
         <p:spPr>
           <a:xfrm>
-            <a:off x="457200" y="2377440"/>
-            <a:ext cx="2651760" cy="1828800"/>
+            <a:off x="457200" y="1965960"/>
+            <a:ext cx="2651760" cy="411480"/>
           </a:xfrm>
           <a:prstGeom prst="rect">
             <a:avLst/>
           </a:prstGeom>
           <a:solidFill>
-            <a:schemeClr val="bg2"/>
+            <a:schemeClr val="accent1"/>
           </a:solidFill>
           <a:ln>
             <a:noFill/>
@@ -32344,49 +32323,7 @@
       </p:sp>
       <p:sp>
         <p:nvSpPr>
-          <p:cNvPr id="16" name="Flow card 1 header"/>
-          <p:cNvSpPr/>
-          <p:nvPr/>
-        </p:nvSpPr>
-        <p:spPr>
-          <a:xfrm>
-            <a:off x="457200" y="1965960"/>
-            <a:ext cx="2651760" cy="411480"/>
-          </a:xfrm>
-          <a:prstGeom prst="rect">
-            <a:avLst/>
-          </a:prstGeom>
-          <a:solidFill>
-            <a:schemeClr val="accent1"/>
-          </a:solidFill>
-          <a:ln>
-            <a:noFill/>
-          </a:ln>
-          <a:effectLst/>
-        </p:spPr>
-        <p:style>
-          <a:lnRef idx="1">
-            <a:schemeClr val="accent1"/>
-          </a:lnRef>
-          <a:fillRef idx="3">
-            <a:schemeClr val="accent1"/>
-          </a:fillRef>
-          <a:effectRef idx="2">
-            <a:schemeClr val="accent1"/>
-          </a:effectRef>
-          <a:fontRef idx="minor">
-            <a:schemeClr val="lt1"/>
-          </a:fontRef>
-        </p:style>
-        <p:txBody>
-          <a:bodyPr rtlCol="0" anchor="ctr"/>
-          <a:lstStyle/>
-          <a:p/>
-        </p:txBody>
-      </p:sp>
-      <p:sp>
-        <p:nvSpPr>
-          <p:cNvPr id="17" name="Flow card 1 heading"/>
+          <p:cNvPr id="16" name="Flow card 1 heading"/>
           <p:cNvSpPr txBox="1"/>
           <p:nvPr/>
         </p:nvSpPr>
@@ -32425,7 +32362,7 @@
       </p:sp>
       <p:pic>
         <p:nvPicPr>
-          <p:cNvPr id="18" name="Icon Flow card 1" descr=""/>
+          <p:cNvPr id="17" name="Icon Flow card 1" descr=""/>
           <p:cNvPicPr>
             <a:picLocks noChangeAspect="1"/>
           </p:cNvPicPr>
@@ -32449,7 +32386,7 @@
       </p:pic>
       <p:sp>
         <p:nvSpPr>
-          <p:cNvPr id="19" name="Flow card 1 text"/>
+          <p:cNvPr id="18" name="Flow card 1 text"/>
           <p:cNvSpPr txBox="1"/>
           <p:nvPr/>
         </p:nvSpPr>
@@ -32485,7 +32422,7 @@
                   <a:schemeClr val="tx1"/>
                 </a:solidFill>
               </a:rPr>
-              <a:t>Pull before every session</a:t>
+              <a:t>Required: pull before every session</a:t>
             </a:r>
           </a:p>
           <a:p>
@@ -32512,7 +32449,7 @@
       </p:sp>
       <p:sp>
         <p:nvSpPr>
-          <p:cNvPr id="20" name="Flow card 2 body"/>
+          <p:cNvPr id="19" name="Flow card 2 body"/>
           <p:cNvSpPr/>
           <p:nvPr/>
         </p:nvSpPr>
@@ -32554,7 +32491,7 @@
       </p:sp>
       <p:sp>
         <p:nvSpPr>
-          <p:cNvPr id="21" name="Flow card 2 header"/>
+          <p:cNvPr id="20" name="Flow card 2 header"/>
           <p:cNvSpPr/>
           <p:nvPr/>
         </p:nvSpPr>
@@ -32596,7 +32533,7 @@
       </p:sp>
       <p:sp>
         <p:nvSpPr>
-          <p:cNvPr id="22" name="Flow card 2 heading"/>
+          <p:cNvPr id="21" name="Flow card 2 heading"/>
           <p:cNvSpPr txBox="1"/>
           <p:nvPr/>
         </p:nvSpPr>
@@ -32635,7 +32572,7 @@
       </p:sp>
       <p:pic>
         <p:nvPicPr>
-          <p:cNvPr id="23" name="Icon Flow card 2" descr=""/>
+          <p:cNvPr id="22" name="Icon Flow card 2" descr=""/>
           <p:cNvPicPr>
             <a:picLocks noChangeAspect="1"/>
           </p:cNvPicPr>
@@ -32659,7 +32596,7 @@
       </p:pic>
       <p:sp>
         <p:nvSpPr>
-          <p:cNvPr id="24" name="Flow card 2 text"/>
+          <p:cNvPr id="23" name="Flow card 2 text"/>
           <p:cNvSpPr txBox="1"/>
           <p:nvPr/>
         </p:nvSpPr>
@@ -32695,7 +32632,7 @@
                   <a:schemeClr val="tx1"/>
                 </a:solidFill>
               </a:rPr>
-              <a:t>Pull, work, commit, push</a:t>
+              <a:t>Optional: one member publishes a private repository</a:t>
             </a:r>
           </a:p>
           <a:p>
@@ -32715,7 +32652,7 @@
                   <a:schemeClr val="tx1"/>
                 </a:solidFill>
               </a:rPr>
-              <a:t>One person per file where you can</a:t>
+              <a:t>Pull, work, commit, push</a:t>
             </a:r>
           </a:p>
           <a:p>
@@ -32735,14 +32672,14 @@
                   <a:schemeClr val="tx1"/>
                 </a:solidFill>
               </a:rPr>
-              <a:t>Push before others start</a:t>
-            </a:r>
-          </a:p>
-        </p:txBody>
-      </p:sp>
-      <p:sp>
-        <p:nvSpPr>
-          <p:cNvPr id="25" name="Flow card 3 body"/>
+              <a:t>One person per file where you can</a:t>
+            </a:r>
+          </a:p>
+        </p:txBody>
+      </p:sp>
+      <p:sp>
+        <p:nvSpPr>
+          <p:cNvPr id="24" name="Flow card 3 body"/>
           <p:cNvSpPr/>
           <p:nvPr/>
         </p:nvSpPr>
@@ -32784,7 +32721,7 @@
       </p:sp>
       <p:sp>
         <p:nvSpPr>
-          <p:cNvPr id="26" name="Flow card 3 header"/>
+          <p:cNvPr id="25" name="Flow card 3 header"/>
           <p:cNvSpPr/>
           <p:nvPr/>
         </p:nvSpPr>
@@ -32826,7 +32763,7 @@
       </p:sp>
       <p:sp>
         <p:nvSpPr>
-          <p:cNvPr id="27" name="Flow card 3 heading"/>
+          <p:cNvPr id="26" name="Flow card 3 heading"/>
           <p:cNvSpPr txBox="1"/>
           <p:nvPr/>
         </p:nvSpPr>
@@ -32865,7 +32802,7 @@
       </p:sp>
       <p:pic>
         <p:nvPicPr>
-          <p:cNvPr id="28" name="Icon Flow card 3" descr=""/>
+          <p:cNvPr id="27" name="Icon Flow card 3" descr=""/>
           <p:cNvPicPr>
             <a:picLocks noChangeAspect="1"/>
           </p:cNvPicPr>
@@ -32889,7 +32826,7 @@
       </p:pic>
       <p:sp>
         <p:nvSpPr>
-          <p:cNvPr id="29" name="Flow card 3 text"/>
+          <p:cNvPr id="28" name="Flow card 3 text"/>
           <p:cNvSpPr txBox="1"/>
           <p:nvPr/>
         </p:nvSpPr>
@@ -32925,7 +32862,7 @@
                   <a:schemeClr val="tx1"/>
                 </a:solidFill>
               </a:rPr>
-              <a:t>Small steps, often</a:t>
+              <a:t>If you commit: small steps, often</a:t>
             </a:r>
           </a:p>
           <a:p>
@@ -32972,7 +32909,7 @@
       </p:sp>
       <p:sp>
         <p:nvSpPr>
-          <p:cNvPr id="30" name="Conflict box"/>
+          <p:cNvPr id="29" name="Conflict box"/>
           <p:cNvSpPr/>
           <p:nvPr/>
         </p:nvSpPr>
@@ -33014,7 +32951,7 @@
       </p:sp>
       <p:pic>
         <p:nvPicPr>
-          <p:cNvPr id="31" name="Icon Conflict" descr=""/>
+          <p:cNvPr id="30" name="Icon Conflict" descr=""/>
           <p:cNvPicPr>
             <a:picLocks noChangeAspect="1"/>
           </p:cNvPicPr>
@@ -33038,7 +32975,7 @@
       </p:pic>
       <p:sp>
         <p:nvSpPr>
-          <p:cNvPr id="32" name="Conflict text"/>
+          <p:cNvPr id="31" name="Conflict text"/>
           <p:cNvSpPr txBox="1"/>
           <p:nvPr/>
         </p:nvSpPr>
@@ -33069,7 +33006,7 @@
                   <a:schemeClr val="bg1"/>
                 </a:solidFill>
               </a:rPr>
-              <a:t>Merge conflict? </a:t>
+              <a:t>Merge conflict in a group repository? </a:t>
             </a:r>
             <a:r>
               <a:rPr sz="1300" b="0" lang="en-GB">
@@ -33077,7 +33014,7 @@
                   <a:schemeClr val="bg1"/>
                 </a:solidFill>
               </a:rPr>
-              <a:t>Open the file, keep the lines you want, delete the conflict markers (&lt;&lt;&lt; === &gt;&gt;&gt;), then commit and push.</a:t>
+              <a:t>Open the file, keep the lines you want, delete the markers (&lt;&lt;&lt; === &gt;&gt;&gt;), then commit and push.</a:t>
             </a:r>
           </a:p>
         </p:txBody>
@@ -33117,7 +33054,7 @@
           <a:p>
             <a:r>
               <a:rPr sz="1600" lang="en-GB"/>
-              <a:t>Your case study as a shared project</a:t>
+              <a:t>Working on the case study together</a:t>
             </a:r>
           </a:p>
         </p:txBody>
@@ -33220,7 +33157,7 @@
                   <a:schemeClr val="tx2"/>
                 </a:solidFill>
               </a:rPr>
-              <a:t>github.com:</a:t>
+              <a:t>Pull course</a:t>
             </a:r>
             <a:br/>
             <a:r>
@@ -33229,7 +33166,7 @@
                   <a:schemeClr val="tx2"/>
                 </a:solidFill>
               </a:rPr>
-              <a:t>new repository</a:t>
+              <a:t>repository</a:t>
             </a:r>
           </a:p>
         </p:txBody>
@@ -33283,7 +33220,7 @@
                   <a:schemeClr val="tx2"/>
                 </a:solidFill>
               </a:rPr>
-              <a:t>Invite</a:t>
+              <a:t>Copy into</a:t>
             </a:r>
             <a:br/>
             <a:r>
@@ -33292,7 +33229,7 @@
                   <a:schemeClr val="tx2"/>
                 </a:solidFill>
               </a:rPr>
-              <a:t>the group</a:t>
+              <a:t>your folder</a:t>
             </a:r>
           </a:p>
         </p:txBody>
@@ -33346,7 +33283,7 @@
                   <a:schemeClr val="tx2"/>
                 </a:solidFill>
               </a:rPr>
-              <a:t>Desktop:</a:t>
+              <a:t>Positron:</a:t>
             </a:r>
             <a:br/>
             <a:r>
@@ -33355,7 +33292,7 @@
                   <a:schemeClr val="tx2"/>
                 </a:solidFill>
               </a:rPr>
-              <a:t>clone</a:t>
+              <a:t>.venv</a:t>
             </a:r>
           </a:p>
         </p:txBody>
@@ -33409,7 +33346,7 @@
                   <a:schemeClr val="tx2"/>
                 </a:solidFill>
               </a:rPr>
-              <a:t>Positron:</a:t>
+              <a:t>Combine:</a:t>
             </a:r>
             <a:br/>
             <a:r>
@@ -33418,7 +33355,7 @@
                   <a:schemeClr val="tx2"/>
                 </a:solidFill>
               </a:rPr>
-              <a:t>Open Folder</a:t>
+              <a:t>2 ways</a:t>
             </a:r>
           </a:p>
         </p:txBody>
@@ -33472,7 +33409,7 @@
                   <a:schemeClr val="tx2"/>
                 </a:solidFill>
               </a:rPr>
-              <a:t>Create</a:t>
+              <a:t>Upload</a:t>
             </a:r>
             <a:br/>
             <a:r>
@@ -33481,7 +33418,7 @@
                   <a:schemeClr val="tx2"/>
                 </a:solidFill>
               </a:rPr>
-              <a:t>.venv</a:t>
+              <a:t>to Canvas</a:t>
             </a:r>
           </a:p>
         </p:txBody>
@@ -33604,7 +33541,7 @@
                 </a:solidFill>
                 <a:latin typeface="+mj-lt"/>
               </a:rPr>
-              <a:t>github.com</a:t>
+              <a:t>Project folder</a:t>
             </a:r>
           </a:p>
         </p:txBody>
@@ -33671,7 +33608,7 @@
                   <a:schemeClr val="tx1"/>
                 </a:solidFill>
               </a:rPr>
-              <a:t>One member creates the repository: Python .gitignore, README</a:t>
+              <a:t>Copy data/case, report.qmd and requirements.txt</a:t>
             </a:r>
           </a:p>
           <a:p>
@@ -33691,179 +33628,9 @@
                   <a:schemeClr val="tx1"/>
                 </a:solidFill>
               </a:rPr>
-              <a:t>Settings → Collaborators: invite the group</a:t>
-            </a:r>
-          </a:p>
-        </p:txBody>
-      </p:sp>
-      <p:sp>
-        <p:nvSpPr>
-          <p:cNvPr id="20" name="Group card 2 body"/>
-          <p:cNvSpPr/>
-          <p:nvPr/>
-        </p:nvSpPr>
-        <p:spPr>
-          <a:xfrm>
-            <a:off x="3246120" y="2377440"/>
-            <a:ext cx="2651760" cy="1828800"/>
-          </a:xfrm>
-          <a:prstGeom prst="rect">
-            <a:avLst/>
-          </a:prstGeom>
-          <a:solidFill>
-            <a:schemeClr val="bg2"/>
-          </a:solidFill>
-          <a:ln>
-            <a:noFill/>
-          </a:ln>
-          <a:effectLst/>
-        </p:spPr>
-        <p:style>
-          <a:lnRef idx="1">
-            <a:schemeClr val="accent1"/>
-          </a:lnRef>
-          <a:fillRef idx="3">
-            <a:schemeClr val="accent1"/>
-          </a:fillRef>
-          <a:effectRef idx="2">
-            <a:schemeClr val="accent1"/>
-          </a:effectRef>
-          <a:fontRef idx="minor">
-            <a:schemeClr val="lt1"/>
-          </a:fontRef>
-        </p:style>
-        <p:txBody>
-          <a:bodyPr rtlCol="0" anchor="ctr"/>
-          <a:lstStyle/>
-          <a:p/>
-        </p:txBody>
-      </p:sp>
-      <p:sp>
-        <p:nvSpPr>
-          <p:cNvPr id="21" name="Group card 2 header"/>
-          <p:cNvSpPr/>
-          <p:nvPr/>
-        </p:nvSpPr>
-        <p:spPr>
-          <a:xfrm>
-            <a:off x="3246120" y="1965960"/>
-            <a:ext cx="2651760" cy="411480"/>
-          </a:xfrm>
-          <a:prstGeom prst="rect">
-            <a:avLst/>
-          </a:prstGeom>
-          <a:solidFill>
-            <a:schemeClr val="accent1"/>
-          </a:solidFill>
-          <a:ln>
-            <a:noFill/>
-          </a:ln>
-          <a:effectLst/>
-        </p:spPr>
-        <p:style>
-          <a:lnRef idx="1">
-            <a:schemeClr val="accent1"/>
-          </a:lnRef>
-          <a:fillRef idx="3">
-            <a:schemeClr val="accent1"/>
-          </a:fillRef>
-          <a:effectRef idx="2">
-            <a:schemeClr val="accent1"/>
-          </a:effectRef>
-          <a:fontRef idx="minor">
-            <a:schemeClr val="lt1"/>
-          </a:fontRef>
-        </p:style>
-        <p:txBody>
-          <a:bodyPr rtlCol="0" anchor="ctr"/>
-          <a:lstStyle/>
-          <a:p/>
-        </p:txBody>
-      </p:sp>
-      <p:sp>
-        <p:nvSpPr>
-          <p:cNvPr id="22" name="Group card 2 heading"/>
-          <p:cNvSpPr txBox="1"/>
-          <p:nvPr/>
-        </p:nvSpPr>
-        <p:spPr>
-          <a:xfrm>
-            <a:off x="3383280" y="1965960"/>
-            <a:ext cx="1965960" cy="411480"/>
-          </a:xfrm>
-          <a:prstGeom prst="rect">
-            <a:avLst/>
-          </a:prstGeom>
-          <a:noFill/>
-        </p:spPr>
-        <p:txBody>
-          <a:bodyPr wrap="square" lIns="0" rIns="0" tIns="0" bIns="0" anchor="ctr">
-            <a:noAutofit/>
-          </a:bodyPr>
-          <a:lstStyle/>
-          <a:p>
-            <a:pPr algn="l">
-              <a:spcAft>
-                <a:spcPts val="400"/>
-              </a:spcAft>
-            </a:pPr>
-            <a:r>
-              <a:rPr sz="1500" b="1" lang="en-GB">
-                <a:solidFill>
-                  <a:schemeClr val="bg1"/>
-                </a:solidFill>
-                <a:latin typeface="+mj-lt"/>
-              </a:rPr>
-              <a:t>GitHub Desktop</a:t>
-            </a:r>
-          </a:p>
-        </p:txBody>
-      </p:sp>
-      <p:pic>
-        <p:nvPicPr>
-          <p:cNvPr id="23" name="Icon Group card 2" descr=""/>
-          <p:cNvPicPr>
-            <a:picLocks noChangeAspect="1"/>
-          </p:cNvPicPr>
-          <p:nvPr/>
-        </p:nvPicPr>
-        <p:blipFill>
-          <a:blip r:embed="rId4"/>
-          <a:stretch>
-            <a:fillRect/>
-          </a:stretch>
-        </p:blipFill>
-        <p:spPr>
-          <a:xfrm>
-            <a:off x="5458968" y="2016252"/>
-            <a:ext cx="310896" cy="310896"/>
-          </a:xfrm>
-          <a:prstGeom prst="rect">
-            <a:avLst/>
-          </a:prstGeom>
-        </p:spPr>
-      </p:pic>
-      <p:sp>
-        <p:nvSpPr>
-          <p:cNvPr id="24" name="Group card 2 text"/>
-          <p:cNvSpPr txBox="1"/>
-          <p:nvPr/>
-        </p:nvSpPr>
-        <p:spPr>
-          <a:xfrm>
-            <a:off x="3410712" y="2514600"/>
-            <a:ext cx="2350008" cy="1554480"/>
-          </a:xfrm>
-          <a:prstGeom prst="rect">
-            <a:avLst/>
-          </a:prstGeom>
-          <a:noFill/>
-        </p:spPr>
-        <p:txBody>
-          <a:bodyPr wrap="square" lIns="0" rIns="0" tIns="0" bIns="0" anchor="t">
-            <a:noAutofit/>
-          </a:bodyPr>
-          <a:lstStyle/>
+              <a:t>report.qmd next to the data folder</a:t>
+            </a:r>
+          </a:p>
           <a:p>
             <a:pPr algn="l" marL="182880" indent="-182880">
               <a:spcAft>
@@ -33881,9 +33648,179 @@
                   <a:schemeClr val="tx1"/>
                 </a:solidFill>
               </a:rPr>
-              <a:t>Pull before you start</a:t>
-            </a:r>
-          </a:p>
+              <a:t>Create Environment from requirements.txt</a:t>
+            </a:r>
+          </a:p>
+        </p:txBody>
+      </p:sp>
+      <p:sp>
+        <p:nvSpPr>
+          <p:cNvPr id="20" name="Group card 2 body"/>
+          <p:cNvSpPr/>
+          <p:nvPr/>
+        </p:nvSpPr>
+        <p:spPr>
+          <a:xfrm>
+            <a:off x="3246120" y="2377440"/>
+            <a:ext cx="2651760" cy="1828800"/>
+          </a:xfrm>
+          <a:prstGeom prst="rect">
+            <a:avLst/>
+          </a:prstGeom>
+          <a:solidFill>
+            <a:schemeClr val="bg2"/>
+          </a:solidFill>
+          <a:ln>
+            <a:noFill/>
+          </a:ln>
+          <a:effectLst/>
+        </p:spPr>
+        <p:style>
+          <a:lnRef idx="1">
+            <a:schemeClr val="accent1"/>
+          </a:lnRef>
+          <a:fillRef idx="3">
+            <a:schemeClr val="accent1"/>
+          </a:fillRef>
+          <a:effectRef idx="2">
+            <a:schemeClr val="accent1"/>
+          </a:effectRef>
+          <a:fontRef idx="minor">
+            <a:schemeClr val="lt1"/>
+          </a:fontRef>
+        </p:style>
+        <p:txBody>
+          <a:bodyPr rtlCol="0" anchor="ctr"/>
+          <a:lstStyle/>
+          <a:p/>
+        </p:txBody>
+      </p:sp>
+      <p:sp>
+        <p:nvSpPr>
+          <p:cNvPr id="21" name="Group card 2 header"/>
+          <p:cNvSpPr/>
+          <p:nvPr/>
+        </p:nvSpPr>
+        <p:spPr>
+          <a:xfrm>
+            <a:off x="3246120" y="1965960"/>
+            <a:ext cx="2651760" cy="411480"/>
+          </a:xfrm>
+          <a:prstGeom prst="rect">
+            <a:avLst/>
+          </a:prstGeom>
+          <a:solidFill>
+            <a:schemeClr val="accent1"/>
+          </a:solidFill>
+          <a:ln>
+            <a:noFill/>
+          </a:ln>
+          <a:effectLst/>
+        </p:spPr>
+        <p:style>
+          <a:lnRef idx="1">
+            <a:schemeClr val="accent1"/>
+          </a:lnRef>
+          <a:fillRef idx="3">
+            <a:schemeClr val="accent1"/>
+          </a:fillRef>
+          <a:effectRef idx="2">
+            <a:schemeClr val="accent1"/>
+          </a:effectRef>
+          <a:fontRef idx="minor">
+            <a:schemeClr val="lt1"/>
+          </a:fontRef>
+        </p:style>
+        <p:txBody>
+          <a:bodyPr rtlCol="0" anchor="ctr"/>
+          <a:lstStyle/>
+          <a:p/>
+        </p:txBody>
+      </p:sp>
+      <p:sp>
+        <p:nvSpPr>
+          <p:cNvPr id="22" name="Group card 2 heading"/>
+          <p:cNvSpPr txBox="1"/>
+          <p:nvPr/>
+        </p:nvSpPr>
+        <p:spPr>
+          <a:xfrm>
+            <a:off x="3383280" y="1965960"/>
+            <a:ext cx="1965960" cy="411480"/>
+          </a:xfrm>
+          <a:prstGeom prst="rect">
+            <a:avLst/>
+          </a:prstGeom>
+          <a:noFill/>
+        </p:spPr>
+        <p:txBody>
+          <a:bodyPr wrap="square" lIns="0" rIns="0" tIns="0" bIns="0" anchor="ctr">
+            <a:noAutofit/>
+          </a:bodyPr>
+          <a:lstStyle/>
+          <a:p>
+            <a:pPr algn="l">
+              <a:spcAft>
+                <a:spcPts val="400"/>
+              </a:spcAft>
+            </a:pPr>
+            <a:r>
+              <a:rPr sz="1500" b="1" lang="en-GB">
+                <a:solidFill>
+                  <a:schemeClr val="bg1"/>
+                </a:solidFill>
+                <a:latin typeface="+mj-lt"/>
+              </a:rPr>
+              <a:t>Way 1: simple</a:t>
+            </a:r>
+          </a:p>
+        </p:txBody>
+      </p:sp>
+      <p:pic>
+        <p:nvPicPr>
+          <p:cNvPr id="23" name="Icon Group card 2" descr=""/>
+          <p:cNvPicPr>
+            <a:picLocks noChangeAspect="1"/>
+          </p:cNvPicPr>
+          <p:nvPr/>
+        </p:nvPicPr>
+        <p:blipFill>
+          <a:blip r:embed="rId4"/>
+          <a:stretch>
+            <a:fillRect/>
+          </a:stretch>
+        </p:blipFill>
+        <p:spPr>
+          <a:xfrm>
+            <a:off x="5458968" y="2016252"/>
+            <a:ext cx="310896" cy="310896"/>
+          </a:xfrm>
+          <a:prstGeom prst="rect">
+            <a:avLst/>
+          </a:prstGeom>
+        </p:spPr>
+      </p:pic>
+      <p:sp>
+        <p:nvSpPr>
+          <p:cNvPr id="24" name="Group card 2 text"/>
+          <p:cNvSpPr txBox="1"/>
+          <p:nvPr/>
+        </p:nvSpPr>
+        <p:spPr>
+          <a:xfrm>
+            <a:off x="3410712" y="2514600"/>
+            <a:ext cx="2350008" cy="1554480"/>
+          </a:xfrm>
+          <a:prstGeom prst="rect">
+            <a:avLst/>
+          </a:prstGeom>
+          <a:noFill/>
+        </p:spPr>
+        <p:txBody>
+          <a:bodyPr wrap="square" lIns="0" rIns="0" tIns="0" bIns="0" anchor="t">
+            <a:noAutofit/>
+          </a:bodyPr>
+          <a:lstStyle/>
           <a:p>
             <a:pPr algn="l" marL="182880" indent="-182880">
               <a:spcAft>
@@ -33901,7 +33838,7 @@
                   <a:schemeClr val="tx1"/>
                 </a:solidFill>
               </a:rPr>
-              <a:t>Commit small steps with a clear message</a:t>
+              <a:t>One member keeps report.qmd</a:t>
             </a:r>
           </a:p>
           <a:p>
@@ -33921,179 +33858,9 @@
                   <a:schemeClr val="tx1"/>
                 </a:solidFill>
               </a:rPr>
-              <a:t>Push when you stop</a:t>
-            </a:r>
-          </a:p>
-        </p:txBody>
-      </p:sp>
-      <p:sp>
-        <p:nvSpPr>
-          <p:cNvPr id="25" name="Group card 3 body"/>
-          <p:cNvSpPr/>
-          <p:nvPr/>
-        </p:nvSpPr>
-        <p:spPr>
-          <a:xfrm>
-            <a:off x="6035040" y="2377440"/>
-            <a:ext cx="2651760" cy="1828800"/>
-          </a:xfrm>
-          <a:prstGeom prst="rect">
-            <a:avLst/>
-          </a:prstGeom>
-          <a:solidFill>
-            <a:schemeClr val="bg2"/>
-          </a:solidFill>
-          <a:ln>
-            <a:noFill/>
-          </a:ln>
-          <a:effectLst/>
-        </p:spPr>
-        <p:style>
-          <a:lnRef idx="1">
-            <a:schemeClr val="accent1"/>
-          </a:lnRef>
-          <a:fillRef idx="3">
-            <a:schemeClr val="accent1"/>
-          </a:fillRef>
-          <a:effectRef idx="2">
-            <a:schemeClr val="accent1"/>
-          </a:effectRef>
-          <a:fontRef idx="minor">
-            <a:schemeClr val="lt1"/>
-          </a:fontRef>
-        </p:style>
-        <p:txBody>
-          <a:bodyPr rtlCol="0" anchor="ctr"/>
-          <a:lstStyle/>
-          <a:p/>
-        </p:txBody>
-      </p:sp>
-      <p:sp>
-        <p:nvSpPr>
-          <p:cNvPr id="26" name="Group card 3 header"/>
-          <p:cNvSpPr/>
-          <p:nvPr/>
-        </p:nvSpPr>
-        <p:spPr>
-          <a:xfrm>
-            <a:off x="6035040" y="1965960"/>
-            <a:ext cx="2651760" cy="411480"/>
-          </a:xfrm>
-          <a:prstGeom prst="rect">
-            <a:avLst/>
-          </a:prstGeom>
-          <a:solidFill>
-            <a:schemeClr val="accent1"/>
-          </a:solidFill>
-          <a:ln>
-            <a:noFill/>
-          </a:ln>
-          <a:effectLst/>
-        </p:spPr>
-        <p:style>
-          <a:lnRef idx="1">
-            <a:schemeClr val="accent1"/>
-          </a:lnRef>
-          <a:fillRef idx="3">
-            <a:schemeClr val="accent1"/>
-          </a:fillRef>
-          <a:effectRef idx="2">
-            <a:schemeClr val="accent1"/>
-          </a:effectRef>
-          <a:fontRef idx="minor">
-            <a:schemeClr val="lt1"/>
-          </a:fontRef>
-        </p:style>
-        <p:txBody>
-          <a:bodyPr rtlCol="0" anchor="ctr"/>
-          <a:lstStyle/>
-          <a:p/>
-        </p:txBody>
-      </p:sp>
-      <p:sp>
-        <p:nvSpPr>
-          <p:cNvPr id="27" name="Group card 3 heading"/>
-          <p:cNvSpPr txBox="1"/>
-          <p:nvPr/>
-        </p:nvSpPr>
-        <p:spPr>
-          <a:xfrm>
-            <a:off x="6172200" y="1965960"/>
-            <a:ext cx="1965960" cy="411480"/>
-          </a:xfrm>
-          <a:prstGeom prst="rect">
-            <a:avLst/>
-          </a:prstGeom>
-          <a:noFill/>
-        </p:spPr>
-        <p:txBody>
-          <a:bodyPr wrap="square" lIns="0" rIns="0" tIns="0" bIns="0" anchor="ctr">
-            <a:noAutofit/>
-          </a:bodyPr>
-          <a:lstStyle/>
-          <a:p>
-            <a:pPr algn="l">
-              <a:spcAft>
-                <a:spcPts val="400"/>
-              </a:spcAft>
-            </a:pPr>
-            <a:r>
-              <a:rPr sz="1500" b="1" lang="en-GB">
-                <a:solidFill>
-                  <a:schemeClr val="bg1"/>
-                </a:solidFill>
-                <a:latin typeface="+mj-lt"/>
-              </a:rPr>
-              <a:t>Positron</a:t>
-            </a:r>
-          </a:p>
-        </p:txBody>
-      </p:sp>
-      <p:pic>
-        <p:nvPicPr>
-          <p:cNvPr id="28" name="Icon Group card 3" descr=""/>
-          <p:cNvPicPr>
-            <a:picLocks noChangeAspect="1"/>
-          </p:cNvPicPr>
-          <p:nvPr/>
-        </p:nvPicPr>
-        <p:blipFill>
-          <a:blip r:embed="rId5"/>
-          <a:stretch>
-            <a:fillRect/>
-          </a:stretch>
-        </p:blipFill>
-        <p:spPr>
-          <a:xfrm>
-            <a:off x="8247888" y="2016252"/>
-            <a:ext cx="310896" cy="310896"/>
-          </a:xfrm>
-          <a:prstGeom prst="rect">
-            <a:avLst/>
-          </a:prstGeom>
-        </p:spPr>
-      </p:pic>
-      <p:sp>
-        <p:nvSpPr>
-          <p:cNvPr id="29" name="Group card 3 text"/>
-          <p:cNvSpPr txBox="1"/>
-          <p:nvPr/>
-        </p:nvSpPr>
-        <p:spPr>
-          <a:xfrm>
-            <a:off x="6199632" y="2514600"/>
-            <a:ext cx="2350008" cy="1554480"/>
-          </a:xfrm>
-          <a:prstGeom prst="rect">
-            <a:avLst/>
-          </a:prstGeom>
-          <a:noFill/>
-        </p:spPr>
-        <p:txBody>
-          <a:bodyPr wrap="square" lIns="0" rIns="0" tIns="0" bIns="0" anchor="t">
-            <a:noAutofit/>
-          </a:bodyPr>
-          <a:lstStyle/>
+              <a:t>The others send code chunks and text</a:t>
+            </a:r>
+          </a:p>
           <a:p>
             <a:pPr algn="l" marL="182880" indent="-182880">
               <a:spcAft>
@@ -34111,9 +33878,179 @@
                   <a:schemeClr val="tx1"/>
                 </a:solidFill>
               </a:rPr>
-              <a:t>Open the cloned folder</a:t>
-            </a:r>
-          </a:p>
+              <a:t>Render the combined file every week</a:t>
+            </a:r>
+          </a:p>
+        </p:txBody>
+      </p:sp>
+      <p:sp>
+        <p:nvSpPr>
+          <p:cNvPr id="25" name="Group card 3 body"/>
+          <p:cNvSpPr/>
+          <p:nvPr/>
+        </p:nvSpPr>
+        <p:spPr>
+          <a:xfrm>
+            <a:off x="6035040" y="2377440"/>
+            <a:ext cx="2651760" cy="1828800"/>
+          </a:xfrm>
+          <a:prstGeom prst="rect">
+            <a:avLst/>
+          </a:prstGeom>
+          <a:solidFill>
+            <a:schemeClr val="bg2"/>
+          </a:solidFill>
+          <a:ln>
+            <a:noFill/>
+          </a:ln>
+          <a:effectLst/>
+        </p:spPr>
+        <p:style>
+          <a:lnRef idx="1">
+            <a:schemeClr val="accent1"/>
+          </a:lnRef>
+          <a:fillRef idx="3">
+            <a:schemeClr val="accent1"/>
+          </a:fillRef>
+          <a:effectRef idx="2">
+            <a:schemeClr val="accent1"/>
+          </a:effectRef>
+          <a:fontRef idx="minor">
+            <a:schemeClr val="lt1"/>
+          </a:fontRef>
+        </p:style>
+        <p:txBody>
+          <a:bodyPr rtlCol="0" anchor="ctr"/>
+          <a:lstStyle/>
+          <a:p/>
+        </p:txBody>
+      </p:sp>
+      <p:sp>
+        <p:nvSpPr>
+          <p:cNvPr id="26" name="Group card 3 header"/>
+          <p:cNvSpPr/>
+          <p:nvPr/>
+        </p:nvSpPr>
+        <p:spPr>
+          <a:xfrm>
+            <a:off x="6035040" y="1965960"/>
+            <a:ext cx="2651760" cy="411480"/>
+          </a:xfrm>
+          <a:prstGeom prst="rect">
+            <a:avLst/>
+          </a:prstGeom>
+          <a:solidFill>
+            <a:schemeClr val="accent1"/>
+          </a:solidFill>
+          <a:ln>
+            <a:noFill/>
+          </a:ln>
+          <a:effectLst/>
+        </p:spPr>
+        <p:style>
+          <a:lnRef idx="1">
+            <a:schemeClr val="accent1"/>
+          </a:lnRef>
+          <a:fillRef idx="3">
+            <a:schemeClr val="accent1"/>
+          </a:fillRef>
+          <a:effectRef idx="2">
+            <a:schemeClr val="accent1"/>
+          </a:effectRef>
+          <a:fontRef idx="minor">
+            <a:schemeClr val="lt1"/>
+          </a:fontRef>
+        </p:style>
+        <p:txBody>
+          <a:bodyPr rtlCol="0" anchor="ctr"/>
+          <a:lstStyle/>
+          <a:p/>
+        </p:txBody>
+      </p:sp>
+      <p:sp>
+        <p:nvSpPr>
+          <p:cNvPr id="27" name="Group card 3 heading"/>
+          <p:cNvSpPr txBox="1"/>
+          <p:nvPr/>
+        </p:nvSpPr>
+        <p:spPr>
+          <a:xfrm>
+            <a:off x="6172200" y="1965960"/>
+            <a:ext cx="1965960" cy="411480"/>
+          </a:xfrm>
+          <a:prstGeom prst="rect">
+            <a:avLst/>
+          </a:prstGeom>
+          <a:noFill/>
+        </p:spPr>
+        <p:txBody>
+          <a:bodyPr wrap="square" lIns="0" rIns="0" tIns="0" bIns="0" anchor="ctr">
+            <a:noAutofit/>
+          </a:bodyPr>
+          <a:lstStyle/>
+          <a:p>
+            <a:pPr algn="l">
+              <a:spcAft>
+                <a:spcPts val="400"/>
+              </a:spcAft>
+            </a:pPr>
+            <a:r>
+              <a:rPr sz="1500" b="1" lang="en-GB">
+                <a:solidFill>
+                  <a:schemeClr val="bg1"/>
+                </a:solidFill>
+                <a:latin typeface="+mj-lt"/>
+              </a:rPr>
+              <a:t>Way 2: GitHub</a:t>
+            </a:r>
+          </a:p>
+        </p:txBody>
+      </p:sp>
+      <p:pic>
+        <p:nvPicPr>
+          <p:cNvPr id="28" name="Icon Group card 3" descr=""/>
+          <p:cNvPicPr>
+            <a:picLocks noChangeAspect="1"/>
+          </p:cNvPicPr>
+          <p:nvPr/>
+        </p:nvPicPr>
+        <p:blipFill>
+          <a:blip r:embed="rId5"/>
+          <a:stretch>
+            <a:fillRect/>
+          </a:stretch>
+        </p:blipFill>
+        <p:spPr>
+          <a:xfrm>
+            <a:off x="8247888" y="2016252"/>
+            <a:ext cx="310896" cy="310896"/>
+          </a:xfrm>
+          <a:prstGeom prst="rect">
+            <a:avLst/>
+          </a:prstGeom>
+        </p:spPr>
+      </p:pic>
+      <p:sp>
+        <p:nvSpPr>
+          <p:cNvPr id="29" name="Group card 3 text"/>
+          <p:cNvSpPr txBox="1"/>
+          <p:nvPr/>
+        </p:nvSpPr>
+        <p:spPr>
+          <a:xfrm>
+            <a:off x="6199632" y="2514600"/>
+            <a:ext cx="2350008" cy="1554480"/>
+          </a:xfrm>
+          <a:prstGeom prst="rect">
+            <a:avLst/>
+          </a:prstGeom>
+          <a:noFill/>
+        </p:spPr>
+        <p:txBody>
+          <a:bodyPr wrap="square" lIns="0" rIns="0" tIns="0" bIns="0" anchor="t">
+            <a:noAutofit/>
+          </a:bodyPr>
+          <a:lstStyle/>
           <a:p>
             <a:pPr algn="l" marL="182880" indent="-182880">
               <a:spcAft>
@@ -34131,7 +34068,7 @@
                   <a:schemeClr val="tx1"/>
                 </a:solidFill>
               </a:rPr>
-              <a:t>Create Environment from requirements.txt (Step 4)</a:t>
+              <a:t>Optional: Publish repository, private</a:t>
             </a:r>
           </a:p>
           <a:p>
@@ -34151,7 +34088,27 @@
                   <a:schemeClr val="tx1"/>
                 </a:solidFill>
               </a:rPr>
-              <a:t>Work, save, then back to Desktop</a:t>
+              <a:t>Invite on github.com: Collaborators</a:t>
+            </a:r>
+          </a:p>
+          <a:p>
+            <a:pPr algn="l" marL="182880" indent="-182880">
+              <a:spcAft>
+                <a:spcPts val="600"/>
+              </a:spcAft>
+              <a:buClr>
+                <a:schemeClr val="accent1"/>
+              </a:buClr>
+              <a:buFont typeface="Arial"/>
+              <a:buChar char="▪"/>
+            </a:pPr>
+            <a:r>
+              <a:rPr sz="1300" b="0" lang="en-GB">
+                <a:solidFill>
+                  <a:schemeClr val="tx1"/>
+                </a:solidFill>
+              </a:rPr>
+              <a:t>Pull, commit, push</a:t>
             </a:r>
           </a:p>
         </p:txBody>
@@ -34207,7 +34164,7 @@
           <p:nvPr/>
         </p:nvPicPr>
         <p:blipFill>
-          <a:blip r:embed="rId6"/>
+          <a:blip r:embed="rId4"/>
           <a:stretch>
             <a:fillRect/>
           </a:stretch>
@@ -34255,7 +34212,7 @@
                   <a:schemeClr val="bg1"/>
                 </a:solidFill>
               </a:rPr>
-              <a:t>Fewer conflicts: </a:t>
+              <a:t>Only Canvas counts: </a:t>
             </a:r>
             <a:r>
               <a:rPr sz="1300" b="0" lang="en-GB">
@@ -34263,7 +34220,7 @@
                   <a:schemeClr val="bg1"/>
                 </a:solidFill>
               </a:rPr>
-              <a:t>pull first, push often, and one person per file where you can.</a:t>
+              <a:t>upload report.qmd and report.html; your commit history is not assessed.</a:t>
             </a:r>
           </a:p>
         </p:txBody>
@@ -45319,7 +45276,7 @@
                   <a:schemeClr val="tx1"/>
                 </a:solidFill>
               </a:rPr>
-              <a:t>Stores code and its history; hosts the course and group repositories</a:t>
+              <a:t>Stores code and its history; hosts the course repository</a:t>
             </a:r>
           </a:p>
         </p:txBody>
@@ -51453,7 +51410,7 @@
                   <a:schemeClr val="tx1"/>
                 </a:solidFill>
               </a:rPr>
-              <a:t>You need it for the group repository of the case study</a:t>
+              <a:t>Optional: share your group's case study in a repository</a:t>
             </a:r>
           </a:p>
           <a:p>
@@ -54554,7 +54511,7 @@
                   <a:schemeClr val="bg1"/>
                 </a:solidFill>
               </a:rPr>
-              <a:t>course and group repositories</a:t>
+              <a:t>the course repository</a:t>
             </a:r>
           </a:p>
         </p:txBody>
@@ -54795,7 +54752,7 @@
                   <a:schemeClr val="tx1"/>
                 </a:solidFill>
               </a:rPr>
-              <a:t>clone, pull and push</a:t>
+              <a:t>clone and pull; push optional</a:t>
             </a:r>
           </a:p>
         </p:txBody>

</xml_diff>

<commit_message>
Stack test as a single plain qmd file
test_stack.qmd installs (one %pip cell, run once in Positron) and loads
polars, plotnine, great_tables and statsmodels, reads the data from the
teaching repository on GitHub and needs no requirements file. Tested in a
fresh Python 3.14 environment with only those pip installs. Set-up deck
slide and guide updated.

Co-Authored-By: Claude Opus 5.5 <noreply@anthropic.com>
Claude-Session: https://claude.ai/code/session_01TbrdxHn7W6FVXXnpqzNytd
</commit_message>
<xml_diff>
--- a/slides/01a_setup-and-registration_WT26-27.pptx
+++ b/slides/01a_setup-and-registration_WT26-27.pptx
@@ -1267,7 +1267,7 @@
           <a:lstStyle/>
           <a:p>
             <a:r>
-              <a:t>test_stack.qmd sits at the top of the course repository. Open it and press Preview: Quarto runs the three cells with the project's .venv and shows a report with a table, a chart and the regression coefficients. The text under it says the model explains 43 % of the weekly variation.</a:t>
+              <a:t>test_stack.qmd is a single file: it installs the packages, loads them and reads the data from the course repository on GitHub, so it also works outside the course folder (internet needed). Run cell 1 once with Ctrl/Cmd + Enter, because Quarto cannot install its own helpers (jupyter) while it renders; pyarrow lets polars hand data to plotnine and statsmodels. Then press Preview: a table, a chart and the regression coefficients appear, and the text says the model explains 43 % of the weekly variation.</a:t>
             </a:r>
           </a:p>
         </p:txBody>
@@ -19030,7 +19030,7 @@
       </p:sp>
       <p:sp>
         <p:nvSpPr>
-          <p:cNvPr id="10" name="Test polars caption bar"/>
+          <p:cNvPr id="10" name="Test install caption bar"/>
           <p:cNvSpPr/>
           <p:nvPr/>
         </p:nvSpPr>
@@ -19072,7 +19072,7 @@
       </p:sp>
       <p:sp>
         <p:nvSpPr>
-          <p:cNvPr id="11" name="Test polars caption"/>
+          <p:cNvPr id="11" name="Test install caption"/>
           <p:cNvSpPr txBox="1"/>
           <p:nvPr/>
         </p:nvSpPr>
@@ -19103,21 +19103,21 @@
                   <a:schemeClr val="bg1"/>
                 </a:solidFill>
               </a:rPr>
-              <a:t>test_stack.qmd · cell 1</a:t>
-            </a:r>
-          </a:p>
-        </p:txBody>
-      </p:sp>
-      <p:sp>
-        <p:nvSpPr>
-          <p:cNvPr id="12" name="Test polars box"/>
+              <a:t>test_stack.qmd · cells 1 and 2</a:t>
+            </a:r>
+          </a:p>
+        </p:txBody>
+      </p:sp>
+      <p:sp>
+        <p:nvSpPr>
+          <p:cNvPr id="12" name="Test install box"/>
           <p:cNvSpPr/>
           <p:nvPr/>
         </p:nvSpPr>
         <p:spPr>
           <a:xfrm>
             <a:off x="457200" y="1508760"/>
-            <a:ext cx="4114800" cy="2514600"/>
+            <a:ext cx="4114800" cy="1417320"/>
           </a:xfrm>
           <a:prstGeom prst="rect">
             <a:avLst/>
@@ -19152,14 +19152,14 @@
       </p:sp>
       <p:sp>
         <p:nvSpPr>
-          <p:cNvPr id="13" name="Test polars code"/>
+          <p:cNvPr id="13" name="Test install code"/>
           <p:cNvSpPr txBox="1"/>
           <p:nvPr/>
         </p:nvSpPr>
         <p:spPr>
           <a:xfrm>
             <a:off x="594360" y="1600200"/>
-            <a:ext cx="3840480" cy="2331720"/>
+            <a:ext cx="3840480" cy="1234440"/>
           </a:xfrm>
           <a:prstGeom prst="rect">
             <a:avLst/>
@@ -19184,7 +19184,7 @@
                 </a:solidFill>
                 <a:latin typeface="Consolas"/>
               </a:rPr>
-              <a:t># polars: sum 2025 revenue by country</a:t>
+              <a:t># 1 Install: run once with Ctrl/Cmd + Enter</a:t>
             </a:r>
           </a:p>
           <a:p>
@@ -19200,7 +19200,7 @@
                 </a:solidFill>
                 <a:latin typeface="Consolas"/>
               </a:rPr>
-              <a:t>import polars as pl</a:t>
+              <a:t>%pip install polars plotnine great-tables \</a:t>
             </a:r>
           </a:p>
           <a:p>
@@ -19216,7 +19216,7 @@
                 </a:solidFill>
                 <a:latin typeface="Consolas"/>
               </a:rPr>
-              <a:t> </a:t>
+              <a:t>    statsmodels pyarrow jupyter</a:t>
             </a:r>
           </a:p>
           <a:p>
@@ -19232,7 +19232,7 @@
                 </a:solidFill>
                 <a:latin typeface="Consolas"/>
               </a:rPr>
-              <a:t>sales = pl.read_csv(</a:t>
+              <a:t># 2 Load</a:t>
             </a:r>
           </a:p>
           <a:p>
@@ -19248,7 +19248,7 @@
                 </a:solidFill>
                 <a:latin typeface="Consolas"/>
               </a:rPr>
-              <a:t>    "data/mmm/alpenglow_weekly.csv",</a:t>
+              <a:t>import polars as pl</a:t>
             </a:r>
           </a:p>
           <a:p>
@@ -19264,7 +19264,7 @@
                 </a:solidFill>
                 <a:latin typeface="Consolas"/>
               </a:rPr>
-              <a:t>    try_parse_dates=True)</a:t>
+              <a:t>import statsmodels.formula.api as smf</a:t>
             </a:r>
           </a:p>
           <a:p>
@@ -19280,7 +19280,7 @@
                 </a:solidFill>
                 <a:latin typeface="Consolas"/>
               </a:rPr>
-              <a:t>summary = (</a:t>
+              <a:t>from great_tables import GT</a:t>
             </a:r>
           </a:p>
           <a:p>
@@ -19296,117 +19296,21 @@
                 </a:solidFill>
                 <a:latin typeface="Consolas"/>
               </a:rPr>
-              <a:t>    sales</a:t>
-            </a:r>
-          </a:p>
-          <a:p>
-            <a:pPr algn="l">
-              <a:spcAft>
-                <a:spcPts val="0"/>
-              </a:spcAft>
-            </a:pPr>
-            <a:r>
-              <a:rPr sz="1000" b="0" lang="en-GB">
-                <a:solidFill>
-                  <a:schemeClr val="bg1"/>
-                </a:solidFill>
-                <a:latin typeface="Consolas"/>
-              </a:rPr>
-              <a:t>    .filter(pl.col("week").dt.year() == 2025)</a:t>
-            </a:r>
-          </a:p>
-          <a:p>
-            <a:pPr algn="l">
-              <a:spcAft>
-                <a:spcPts val="0"/>
-              </a:spcAft>
-            </a:pPr>
-            <a:r>
-              <a:rPr sz="1000" b="0" lang="en-GB">
-                <a:solidFill>
-                  <a:schemeClr val="bg1"/>
-                </a:solidFill>
-                <a:latin typeface="Consolas"/>
-              </a:rPr>
-              <a:t>    .group_by("country")</a:t>
-            </a:r>
-          </a:p>
-          <a:p>
-            <a:pPr algn="l">
-              <a:spcAft>
-                <a:spcPts val="0"/>
-              </a:spcAft>
-            </a:pPr>
-            <a:r>
-              <a:rPr sz="1000" b="0" lang="en-GB">
-                <a:solidFill>
-                  <a:schemeClr val="bg1"/>
-                </a:solidFill>
-                <a:latin typeface="Consolas"/>
-              </a:rPr>
-              <a:t>    .agg(pl.col("revenue_eur_k").sum())</a:t>
-            </a:r>
-          </a:p>
-          <a:p>
-            <a:pPr algn="l">
-              <a:spcAft>
-                <a:spcPts val="0"/>
-              </a:spcAft>
-            </a:pPr>
-            <a:r>
-              <a:rPr sz="1000" b="0" lang="en-GB">
-                <a:solidFill>
-                  <a:schemeClr val="bg1"/>
-                </a:solidFill>
-                <a:latin typeface="Consolas"/>
-              </a:rPr>
-              <a:t>    .sort("revenue_eur_k", descending=True)</a:t>
-            </a:r>
-          </a:p>
-          <a:p>
-            <a:pPr algn="l">
-              <a:spcAft>
-                <a:spcPts val="0"/>
-              </a:spcAft>
-            </a:pPr>
-            <a:r>
-              <a:rPr sz="1000" b="0" lang="en-GB">
-                <a:solidFill>
-                  <a:schemeClr val="bg1"/>
-                </a:solidFill>
-                <a:latin typeface="Consolas"/>
-              </a:rPr>
-              <a:t>)</a:t>
-            </a:r>
-          </a:p>
-          <a:p>
-            <a:pPr algn="l">
-              <a:spcAft>
-                <a:spcPts val="0"/>
-              </a:spcAft>
-            </a:pPr>
-            <a:r>
-              <a:rPr sz="1000" b="0" lang="en-GB">
-                <a:solidFill>
-                  <a:schemeClr val="bg1"/>
-                </a:solidFill>
-                <a:latin typeface="Consolas"/>
-              </a:rPr>
-              <a:t>summary</a:t>
-            </a:r>
-          </a:p>
-        </p:txBody>
-      </p:sp>
-      <p:sp>
-        <p:nvSpPr>
-          <p:cNvPr id="14" name="Test plotnine caption bar"/>
+              <a:t>from plotnine import ggplot, aes, geom_line</a:t>
+            </a:r>
+          </a:p>
+        </p:txBody>
+      </p:sp>
+      <p:sp>
+        <p:nvSpPr>
+          <p:cNvPr id="14" name="Test polars caption bar"/>
           <p:cNvSpPr/>
           <p:nvPr/>
         </p:nvSpPr>
         <p:spPr>
           <a:xfrm>
-            <a:off x="4709160" y="1234440"/>
-            <a:ext cx="3977640" cy="274320"/>
+            <a:off x="457200" y="3017520"/>
+            <a:ext cx="4114800" cy="274320"/>
           </a:xfrm>
           <a:prstGeom prst="rect">
             <a:avLst/>
@@ -19441,14 +19345,14 @@
       </p:sp>
       <p:sp>
         <p:nvSpPr>
-          <p:cNvPr id="15" name="Test plotnine caption"/>
+          <p:cNvPr id="15" name="Test polars caption"/>
           <p:cNvSpPr txBox="1"/>
           <p:nvPr/>
         </p:nvSpPr>
         <p:spPr>
           <a:xfrm>
-            <a:off x="4818888" y="1234440"/>
-            <a:ext cx="3758184" cy="274320"/>
+            <a:off x="566928" y="3017520"/>
+            <a:ext cx="3895344" cy="274320"/>
           </a:xfrm>
           <a:prstGeom prst="rect">
             <a:avLst/>
@@ -19472,21 +19376,21 @@
                   <a:schemeClr val="bg1"/>
                 </a:solidFill>
               </a:rPr>
-              <a:t>cell 2</a:t>
-            </a:r>
-          </a:p>
-        </p:txBody>
-      </p:sp>
-      <p:sp>
-        <p:nvSpPr>
-          <p:cNvPr id="16" name="Test plotnine box"/>
+              <a:t>cells 3 and 4</a:t>
+            </a:r>
+          </a:p>
+        </p:txBody>
+      </p:sp>
+      <p:sp>
+        <p:nvSpPr>
+          <p:cNvPr id="16" name="Test polars box"/>
           <p:cNvSpPr/>
           <p:nvPr/>
         </p:nvSpPr>
         <p:spPr>
           <a:xfrm>
-            <a:off x="4709160" y="1508760"/>
-            <a:ext cx="3977640" cy="1143000"/>
+            <a:off x="457200" y="3291840"/>
+            <a:ext cx="4114800" cy="1280160"/>
           </a:xfrm>
           <a:prstGeom prst="rect">
             <a:avLst/>
@@ -19521,14 +19425,14 @@
       </p:sp>
       <p:sp>
         <p:nvSpPr>
-          <p:cNvPr id="17" name="Test plotnine code"/>
+          <p:cNvPr id="17" name="Test polars code"/>
           <p:cNvSpPr txBox="1"/>
           <p:nvPr/>
         </p:nvSpPr>
         <p:spPr>
           <a:xfrm>
-            <a:off x="4846320" y="1600200"/>
-            <a:ext cx="3703320" cy="960120"/>
+            <a:off x="594360" y="3383280"/>
+            <a:ext cx="3840480" cy="1097280"/>
           </a:xfrm>
           <a:prstGeom prst="rect">
             <a:avLst/>
@@ -19553,7 +19457,7 @@
                 </a:solidFill>
                 <a:latin typeface="Consolas"/>
               </a:rPr>
-              <a:t># plotnine: weekly sales, AT and DE</a:t>
+              <a:t># 3-4 polars and great_tables</a:t>
             </a:r>
           </a:p>
           <a:p>
@@ -19569,7 +19473,7 @@
                 </a:solidFill>
                 <a:latin typeface="Consolas"/>
               </a:rPr>
-              <a:t>from plotnine import ggplot, aes, geom_line</a:t>
+              <a:t>sales = pl.read_csv(URL, try_parse_dates=True)</a:t>
             </a:r>
           </a:p>
           <a:p>
@@ -19585,7 +19489,7 @@
                 </a:solidFill>
                 <a:latin typeface="Consolas"/>
               </a:rPr>
-              <a:t>two = sales.filter(</a:t>
+              <a:t>summary = (sales</a:t>
             </a:r>
           </a:p>
           <a:p>
@@ -19601,7 +19505,7 @@
                 </a:solidFill>
                 <a:latin typeface="Consolas"/>
               </a:rPr>
-              <a:t>    pl.col("country").is_in(["AT", "DE"]))</a:t>
+              <a:t>  .filter(pl.col("week").dt.year() == 2025)</a:t>
             </a:r>
           </a:p>
           <a:p>
@@ -19617,7 +19521,7 @@
                 </a:solidFill>
                 <a:latin typeface="Consolas"/>
               </a:rPr>
-              <a:t>ggplot(two, aes("week", "sales_units_k",</a:t>
+              <a:t>  .group_by("country")</a:t>
             </a:r>
           </a:p>
           <a:p>
@@ -19633,20 +19537,36 @@
                 </a:solidFill>
                 <a:latin typeface="Consolas"/>
               </a:rPr>
-              <a:t>                color="country")) + geom_line()</a:t>
-            </a:r>
-          </a:p>
-        </p:txBody>
-      </p:sp>
-      <p:sp>
-        <p:nvSpPr>
-          <p:cNvPr id="18" name="Test statsmodels caption bar"/>
+              <a:t>  .agg(pl.col("revenue_eur_k").sum()))</a:t>
+            </a:r>
+          </a:p>
+          <a:p>
+            <a:pPr algn="l">
+              <a:spcAft>
+                <a:spcPts val="0"/>
+              </a:spcAft>
+            </a:pPr>
+            <a:r>
+              <a:rPr sz="1000" b="0" lang="en-GB">
+                <a:solidFill>
+                  <a:schemeClr val="bg1"/>
+                </a:solidFill>
+                <a:latin typeface="Consolas"/>
+              </a:rPr>
+              <a:t>GT(summary)</a:t>
+            </a:r>
+          </a:p>
+        </p:txBody>
+      </p:sp>
+      <p:sp>
+        <p:nvSpPr>
+          <p:cNvPr id="18" name="Test plotnine caption bar"/>
           <p:cNvSpPr/>
           <p:nvPr/>
         </p:nvSpPr>
         <p:spPr>
           <a:xfrm>
-            <a:off x="4709160" y="2743200"/>
+            <a:off x="4709160" y="1234440"/>
             <a:ext cx="3977640" cy="274320"/>
           </a:xfrm>
           <a:prstGeom prst="rect">
@@ -19682,13 +19602,13 @@
       </p:sp>
       <p:sp>
         <p:nvSpPr>
-          <p:cNvPr id="19" name="Test statsmodels caption"/>
+          <p:cNvPr id="19" name="Test plotnine caption"/>
           <p:cNvSpPr txBox="1"/>
           <p:nvPr/>
         </p:nvSpPr>
         <p:spPr>
           <a:xfrm>
-            <a:off x="4818888" y="2743200"/>
+            <a:off x="4818888" y="1234440"/>
             <a:ext cx="3758184" cy="274320"/>
           </a:xfrm>
           <a:prstGeom prst="rect">
@@ -19713,21 +19633,21 @@
                   <a:schemeClr val="bg1"/>
                 </a:solidFill>
               </a:rPr>
-              <a:t>cell 3</a:t>
-            </a:r>
-          </a:p>
-        </p:txBody>
-      </p:sp>
-      <p:sp>
-        <p:nvSpPr>
-          <p:cNvPr id="20" name="Test statsmodels box"/>
+              <a:t>cell 5</a:t>
+            </a:r>
+          </a:p>
+        </p:txBody>
+      </p:sp>
+      <p:sp>
+        <p:nvSpPr>
+          <p:cNvPr id="20" name="Test plotnine box"/>
           <p:cNvSpPr/>
           <p:nvPr/>
         </p:nvSpPr>
         <p:spPr>
           <a:xfrm>
-            <a:off x="4709160" y="3017520"/>
-            <a:ext cx="3977640" cy="1554480"/>
+            <a:off x="4709160" y="1508760"/>
+            <a:ext cx="3977640" cy="1143000"/>
           </a:xfrm>
           <a:prstGeom prst="rect">
             <a:avLst/>
@@ -19762,14 +19682,14 @@
       </p:sp>
       <p:sp>
         <p:nvSpPr>
-          <p:cNvPr id="21" name="Test statsmodels code"/>
+          <p:cNvPr id="21" name="Test plotnine code"/>
           <p:cNvSpPr txBox="1"/>
           <p:nvPr/>
         </p:nvSpPr>
         <p:spPr>
           <a:xfrm>
-            <a:off x="4846320" y="3108960"/>
-            <a:ext cx="3703320" cy="1371600"/>
+            <a:off x="4846320" y="1600200"/>
+            <a:ext cx="3703320" cy="960120"/>
           </a:xfrm>
           <a:prstGeom prst="rect">
             <a:avLst/>
@@ -19794,7 +19714,7 @@
                 </a:solidFill>
                 <a:latin typeface="Consolas"/>
               </a:rPr>
-              <a:t># statsmodels: regression for Austria</a:t>
+              <a:t># 5 plotnine: weekly sales, AT and DE</a:t>
             </a:r>
           </a:p>
           <a:p>
@@ -19810,7 +19730,7 @@
                 </a:solidFill>
                 <a:latin typeface="Consolas"/>
               </a:rPr>
-              <a:t>import statsmodels.formula.api as smf</a:t>
+              <a:t>two = sales.filter(</a:t>
             </a:r>
           </a:p>
           <a:p>
@@ -19826,7 +19746,7 @@
                 </a:solidFill>
                 <a:latin typeface="Consolas"/>
               </a:rPr>
-              <a:t>at = (sales.filter(pl.col("country") == "AT")</a:t>
+              <a:t>    pl.col("country").is_in(["AT", "DE"]))</a:t>
             </a:r>
           </a:p>
           <a:p>
@@ -19842,7 +19762,7 @@
                 </a:solidFill>
                 <a:latin typeface="Consolas"/>
               </a:rPr>
-              <a:t>      .to_pandas())</a:t>
+              <a:t>ggplot(two, aes("week", "sales_units_k",</a:t>
             </a:r>
           </a:p>
           <a:p>
@@ -19858,9 +19778,154 @@
                 </a:solidFill>
                 <a:latin typeface="Consolas"/>
               </a:rPr>
-              <a:t>model = smf.ols(</a:t>
-            </a:r>
-          </a:p>
+              <a:t>                color="country")) + geom_line()</a:t>
+            </a:r>
+          </a:p>
+        </p:txBody>
+      </p:sp>
+      <p:sp>
+        <p:nvSpPr>
+          <p:cNvPr id="22" name="Test statsmodels caption bar"/>
+          <p:cNvSpPr/>
+          <p:nvPr/>
+        </p:nvSpPr>
+        <p:spPr>
+          <a:xfrm>
+            <a:off x="4709160" y="2743200"/>
+            <a:ext cx="3977640" cy="274320"/>
+          </a:xfrm>
+          <a:prstGeom prst="rect">
+            <a:avLst/>
+          </a:prstGeom>
+          <a:solidFill>
+            <a:schemeClr val="accent1"/>
+          </a:solidFill>
+          <a:ln>
+            <a:noFill/>
+          </a:ln>
+          <a:effectLst/>
+        </p:spPr>
+        <p:style>
+          <a:lnRef idx="1">
+            <a:schemeClr val="accent1"/>
+          </a:lnRef>
+          <a:fillRef idx="3">
+            <a:schemeClr val="accent1"/>
+          </a:fillRef>
+          <a:effectRef idx="2">
+            <a:schemeClr val="accent1"/>
+          </a:effectRef>
+          <a:fontRef idx="minor">
+            <a:schemeClr val="lt1"/>
+          </a:fontRef>
+        </p:style>
+        <p:txBody>
+          <a:bodyPr rtlCol="0" anchor="ctr"/>
+          <a:lstStyle/>
+          <a:p/>
+        </p:txBody>
+      </p:sp>
+      <p:sp>
+        <p:nvSpPr>
+          <p:cNvPr id="23" name="Test statsmodels caption"/>
+          <p:cNvSpPr txBox="1"/>
+          <p:nvPr/>
+        </p:nvSpPr>
+        <p:spPr>
+          <a:xfrm>
+            <a:off x="4818888" y="2743200"/>
+            <a:ext cx="3758184" cy="274320"/>
+          </a:xfrm>
+          <a:prstGeom prst="rect">
+            <a:avLst/>
+          </a:prstGeom>
+          <a:noFill/>
+        </p:spPr>
+        <p:txBody>
+          <a:bodyPr wrap="square" lIns="0" rIns="0" tIns="0" bIns="0" anchor="ctr">
+            <a:noAutofit/>
+          </a:bodyPr>
+          <a:lstStyle/>
+          <a:p>
+            <a:pPr algn="l">
+              <a:spcAft>
+                <a:spcPts val="400"/>
+              </a:spcAft>
+            </a:pPr>
+            <a:r>
+              <a:rPr sz="1100" b="1" lang="en-GB">
+                <a:solidFill>
+                  <a:schemeClr val="bg1"/>
+                </a:solidFill>
+              </a:rPr>
+              <a:t>cell 6</a:t>
+            </a:r>
+          </a:p>
+        </p:txBody>
+      </p:sp>
+      <p:sp>
+        <p:nvSpPr>
+          <p:cNvPr id="24" name="Test statsmodels box"/>
+          <p:cNvSpPr/>
+          <p:nvPr/>
+        </p:nvSpPr>
+        <p:spPr>
+          <a:xfrm>
+            <a:off x="4709160" y="3017520"/>
+            <a:ext cx="3977640" cy="1097280"/>
+          </a:xfrm>
+          <a:prstGeom prst="rect">
+            <a:avLst/>
+          </a:prstGeom>
+          <a:solidFill>
+            <a:schemeClr val="tx2"/>
+          </a:solidFill>
+          <a:ln>
+            <a:noFill/>
+          </a:ln>
+          <a:effectLst/>
+        </p:spPr>
+        <p:style>
+          <a:lnRef idx="1">
+            <a:schemeClr val="accent1"/>
+          </a:lnRef>
+          <a:fillRef idx="3">
+            <a:schemeClr val="accent1"/>
+          </a:fillRef>
+          <a:effectRef idx="2">
+            <a:schemeClr val="accent1"/>
+          </a:effectRef>
+          <a:fontRef idx="minor">
+            <a:schemeClr val="lt1"/>
+          </a:fontRef>
+        </p:style>
+        <p:txBody>
+          <a:bodyPr rtlCol="0" anchor="ctr"/>
+          <a:lstStyle/>
+          <a:p/>
+        </p:txBody>
+      </p:sp>
+      <p:sp>
+        <p:nvSpPr>
+          <p:cNvPr id="25" name="Test statsmodels code"/>
+          <p:cNvSpPr txBox="1"/>
+          <p:nvPr/>
+        </p:nvSpPr>
+        <p:spPr>
+          <a:xfrm>
+            <a:off x="4846320" y="3108960"/>
+            <a:ext cx="3703320" cy="914400"/>
+          </a:xfrm>
+          <a:prstGeom prst="rect">
+            <a:avLst/>
+          </a:prstGeom>
+          <a:noFill/>
+        </p:spPr>
+        <p:txBody>
+          <a:bodyPr wrap="square" lIns="0" rIns="0" tIns="0" bIns="0" anchor="t">
+            <a:noAutofit/>
+          </a:bodyPr>
+          <a:lstStyle/>
           <a:p>
             <a:pPr algn="l">
               <a:spcAft>
@@ -19874,7 +19939,7 @@
                 </a:solidFill>
                 <a:latin typeface="Consolas"/>
               </a:rPr>
-              <a:t>    "sales_units_k ~ price_eur + spend_tv_k"</a:t>
+              <a:t># 6 statsmodels: regression for Austria</a:t>
             </a:r>
           </a:p>
           <a:p>
@@ -19890,7 +19955,7 @@
                 </a:solidFill>
                 <a:latin typeface="Consolas"/>
               </a:rPr>
-              <a:t>    " + spend_paid_search_k", data=at).fit()</a:t>
+              <a:t>at = sales.filter(</a:t>
             </a:r>
           </a:p>
           <a:p>
@@ -19906,21 +19971,69 @@
                 </a:solidFill>
                 <a:latin typeface="Consolas"/>
               </a:rPr>
-              <a:t>model.params.round(2)</a:t>
-            </a:r>
-          </a:p>
-        </p:txBody>
-      </p:sp>
-      <p:sp>
-        <p:nvSpPr>
-          <p:cNvPr id="22" name="Test result box"/>
+              <a:t>    pl.col("country") == "AT").to_pandas()</a:t>
+            </a:r>
+          </a:p>
+          <a:p>
+            <a:pPr algn="l">
+              <a:spcAft>
+                <a:spcPts val="0"/>
+              </a:spcAft>
+            </a:pPr>
+            <a:r>
+              <a:rPr sz="1000" b="0" lang="en-GB">
+                <a:solidFill>
+                  <a:schemeClr val="bg1"/>
+                </a:solidFill>
+                <a:latin typeface="Consolas"/>
+              </a:rPr>
+              <a:t>model = smf.ols("sales_units_k ~ price_eur"</a:t>
+            </a:r>
+          </a:p>
+          <a:p>
+            <a:pPr algn="l">
+              <a:spcAft>
+                <a:spcPts val="0"/>
+              </a:spcAft>
+            </a:pPr>
+            <a:r>
+              <a:rPr sz="1000" b="0" lang="en-GB">
+                <a:solidFill>
+                  <a:schemeClr val="bg1"/>
+                </a:solidFill>
+                <a:latin typeface="Consolas"/>
+              </a:rPr>
+              <a:t>    " + spend_tv_k + spend_paid_search_k",</a:t>
+            </a:r>
+          </a:p>
+          <a:p>
+            <a:pPr algn="l">
+              <a:spcAft>
+                <a:spcPts val="0"/>
+              </a:spcAft>
+            </a:pPr>
+            <a:r>
+              <a:rPr sz="1000" b="0" lang="en-GB">
+                <a:solidFill>
+                  <a:schemeClr val="bg1"/>
+                </a:solidFill>
+                <a:latin typeface="Consolas"/>
+              </a:rPr>
+              <a:t>    data=at).fit()</a:t>
+            </a:r>
+          </a:p>
+        </p:txBody>
+      </p:sp>
+      <p:sp>
+        <p:nvSpPr>
+          <p:cNvPr id="26" name="Test result box"/>
           <p:cNvSpPr/>
           <p:nvPr/>
         </p:nvSpPr>
         <p:spPr>
           <a:xfrm>
-            <a:off x="457200" y="4114800"/>
-            <a:ext cx="4114800" cy="457200"/>
+            <a:off x="4709160" y="4206240"/>
+            <a:ext cx="3977640" cy="365760"/>
           </a:xfrm>
           <a:prstGeom prst="rect">
             <a:avLst/>
@@ -19955,14 +20068,14 @@
       </p:sp>
       <p:sp>
         <p:nvSpPr>
-          <p:cNvPr id="23" name="Test result"/>
+          <p:cNvPr id="27" name="Test result"/>
           <p:cNvSpPr txBox="1"/>
           <p:nvPr/>
         </p:nvSpPr>
         <p:spPr>
           <a:xfrm>
-            <a:off x="594360" y="4114800"/>
-            <a:ext cx="3931920" cy="457200"/>
+            <a:off x="4846320" y="4206240"/>
+            <a:ext cx="3794760" cy="365760"/>
           </a:xfrm>
           <a:prstGeom prst="rect">
             <a:avLst/>
@@ -19994,14 +20107,14 @@
                   <a:schemeClr val="tx1"/>
                 </a:solidFill>
               </a:rPr>
-              <a:t>a table, a chart and four coefficients</a:t>
-            </a:r>
-          </a:p>
-        </p:txBody>
-      </p:sp>
-      <p:sp>
-        <p:nvSpPr>
-          <p:cNvPr id="24" name="Test run box"/>
+              <a:t>a table, a chart, the coefficients</a:t>
+            </a:r>
+          </a:p>
+        </p:txBody>
+      </p:sp>
+      <p:sp>
+        <p:nvSpPr>
+          <p:cNvPr id="28" name="Test run box"/>
           <p:cNvSpPr/>
           <p:nvPr/>
         </p:nvSpPr>
@@ -20043,7 +20156,7 @@
       </p:sp>
       <p:pic>
         <p:nvPicPr>
-          <p:cNvPr id="25" name="Icon Test run" descr=""/>
+          <p:cNvPr id="29" name="Icon Test run" descr=""/>
           <p:cNvPicPr>
             <a:picLocks noChangeAspect="1"/>
           </p:cNvPicPr>
@@ -20067,7 +20180,7 @@
       </p:pic>
       <p:sp>
         <p:nvSpPr>
-          <p:cNvPr id="26" name="Test run text"/>
+          <p:cNvPr id="30" name="Test run text"/>
           <p:cNvSpPr txBox="1"/>
           <p:nvPr/>
         </p:nvSpPr>
@@ -20106,7 +20219,7 @@
                   <a:schemeClr val="tx1"/>
                 </a:solidFill>
               </a:rPr>
-              <a:t>open test_stack.qmd in Positron and press Preview (Ctrl/Cmd + Shift + K).</a:t>
+              <a:t>cell 1 once with Ctrl/Cmd + Enter, then Preview (Ctrl/Cmd + Shift + K).</a:t>
             </a:r>
           </a:p>
         </p:txBody>

</xml_diff>

<commit_message>
Set-up deck: .venv fix on the stack-test slide and in troubleshooting
Slide 15 tells students to pick Python 3.14.8 (.venv) before running the
install cell and shows the command that installs straight into .venv when
Preview reports "No module named 'yaml'" (full commands in the notes). The
troubleshooting table gains the same case and is shortened to fit.

Co-Authored-By: Claude Opus 5.5 <noreply@anthropic.com>
Claude-Session: https://claude.ai/code/session_01TbrdxHn7W6FVXXnpqzNytd
</commit_message>
<xml_diff>
--- a/slides/01a_setup-and-registration_WT26-27.pptx
+++ b/slides/01a_setup-and-registration_WT26-27.pptx
@@ -1272,7 +1272,7 @@
           <a:lstStyle/>
           <a:p>
             <a:r>
-              <a:t>test_stack.qmd is a single file: it installs the packages, loads them and reads the data from the course repository on GitHub, so it also works outside the course folder (internet needed). Run cell 1 once with Ctrl/Cmd + Enter, because Quarto cannot install its own helpers (jupyter) while it renders; pyarrow lets polars hand data to plotnine and statsmodels. Then press Preview: a table, a chart and the regression coefficients appear, and the text says the model explains 43 % of the weekly variation.</a:t>
+              <a:t>test_stack.qmd is a single file: it installs the packages, loads them and reads the data from the course repository on GitHub, so it also works outside the course folder (internet needed). Run cell 1 once with Ctrl/Cmd + Enter, because Quarto cannot install its own helpers (jupyter) while it renders; pyarrow lets polars hand data to plotnine and statsmodels. Then press Preview: a table, a chart and the regression coefficients appear, and the text says the model explains 43 % of the weekly variation. If the folder has a .venv, Quarto runs the file with it, so pick Python 3.14.8 (.venv) before running cell 1. Error 'No module named yaml' or 'unactivated Python environment in .venv': the packages went to another Python. Fix in Positron's terminal: Windows .venv\Scripts\python -m pip install polars plotnine great-tables statsmodels pyarrow jupyter; macOS .venv/bin/python -m pip install (same list).</a:t>
             </a:r>
           </a:p>
         </p:txBody>
@@ -20002,7 +20002,7 @@
         <p:spPr>
           <a:xfrm>
             <a:off x="4709160" y="1508760"/>
-            <a:ext cx="3977640" cy="1143000"/>
+            <a:ext cx="3977640" cy="1005840"/>
           </a:xfrm>
           <a:prstGeom prst="rect">
             <a:avLst/>
@@ -20044,7 +20044,7 @@
         <p:spPr>
           <a:xfrm>
             <a:off x="4846320" y="1600200"/>
-            <a:ext cx="3703320" cy="960120"/>
+            <a:ext cx="3703320" cy="822960"/>
           </a:xfrm>
           <a:prstGeom prst="rect">
             <a:avLst/>
@@ -20146,7 +20146,7 @@
         </p:nvSpPr>
         <p:spPr>
           <a:xfrm>
-            <a:off x="4709160" y="2743200"/>
+            <a:off x="4709160" y="2587752"/>
             <a:ext cx="3977640" cy="274320"/>
           </a:xfrm>
           <a:prstGeom prst="rect">
@@ -20188,7 +20188,7 @@
         </p:nvSpPr>
         <p:spPr>
           <a:xfrm>
-            <a:off x="4818888" y="2743200"/>
+            <a:off x="4818888" y="2587752"/>
             <a:ext cx="3758184" cy="274320"/>
           </a:xfrm>
           <a:prstGeom prst="rect">
@@ -20226,8 +20226,8 @@
         </p:nvSpPr>
         <p:spPr>
           <a:xfrm>
-            <a:off x="4709160" y="3017520"/>
-            <a:ext cx="3977640" cy="1097280"/>
+            <a:off x="4709160" y="2862072"/>
+            <a:ext cx="3977640" cy="1051560"/>
           </a:xfrm>
           <a:prstGeom prst="rect">
             <a:avLst/>
@@ -20268,8 +20268,8 @@
         </p:nvSpPr>
         <p:spPr>
           <a:xfrm>
-            <a:off x="4846320" y="3108960"/>
-            <a:ext cx="3703320" cy="914400"/>
+            <a:off x="4846320" y="2953512"/>
+            <a:ext cx="3703320" cy="868680"/>
           </a:xfrm>
           <a:prstGeom prst="rect">
             <a:avLst/>
@@ -20381,14 +20381,14 @@
       </p:sp>
       <p:sp>
         <p:nvSpPr>
-          <p:cNvPr id="26" name="Test result box"/>
+          <p:cNvPr id="26" name="Venv fix box"/>
           <p:cNvSpPr/>
           <p:nvPr/>
         </p:nvSpPr>
         <p:spPr>
           <a:xfrm>
-            <a:off x="4709160" y="4206240"/>
-            <a:ext cx="3977640" cy="365760"/>
+            <a:off x="4709160" y="3986784"/>
+            <a:ext cx="3977640" cy="585216"/>
           </a:xfrm>
           <a:prstGeom prst="rect">
             <a:avLst/>
@@ -20423,14 +20423,56 @@
       </p:sp>
       <p:sp>
         <p:nvSpPr>
-          <p:cNvPr id="27" name="Test result"/>
+          <p:cNvPr id="27" name="Venv fix bar"/>
+          <p:cNvSpPr/>
+          <p:nvPr/>
+        </p:nvSpPr>
+        <p:spPr>
+          <a:xfrm>
+            <a:off x="4709160" y="3986784"/>
+            <a:ext cx="64008" cy="585216"/>
+          </a:xfrm>
+          <a:prstGeom prst="rect">
+            <a:avLst/>
+          </a:prstGeom>
+          <a:solidFill>
+            <a:schemeClr val="accent1"/>
+          </a:solidFill>
+          <a:ln>
+            <a:noFill/>
+          </a:ln>
+          <a:effectLst/>
+        </p:spPr>
+        <p:style>
+          <a:lnRef idx="1">
+            <a:schemeClr val="accent1"/>
+          </a:lnRef>
+          <a:fillRef idx="3">
+            <a:schemeClr val="accent1"/>
+          </a:fillRef>
+          <a:effectRef idx="2">
+            <a:schemeClr val="accent1"/>
+          </a:effectRef>
+          <a:fontRef idx="minor">
+            <a:schemeClr val="lt1"/>
+          </a:fontRef>
+        </p:style>
+        <p:txBody>
+          <a:bodyPr rtlCol="0" anchor="ctr"/>
+          <a:lstStyle/>
+          <a:p/>
+        </p:txBody>
+      </p:sp>
+      <p:sp>
+        <p:nvSpPr>
+          <p:cNvPr id="28" name="Venv fix text"/>
           <p:cNvSpPr txBox="1"/>
           <p:nvPr/>
         </p:nvSpPr>
         <p:spPr>
           <a:xfrm>
-            <a:off x="4846320" y="4206240"/>
-            <a:ext cx="3794760" cy="365760"/>
+            <a:off x="4864608" y="3986784"/>
+            <a:ext cx="3776472" cy="585216"/>
           </a:xfrm>
           <a:prstGeom prst="rect">
             <a:avLst/>
@@ -20445,31 +20487,47 @@
           <a:p>
             <a:pPr algn="l">
               <a:spcAft>
-                <a:spcPts val="400"/>
+                <a:spcPts val="200"/>
               </a:spcAft>
             </a:pPr>
             <a:r>
-              <a:rPr sz="1200" b="1" lang="en-GB">
+              <a:rPr sz="1100" b="1" lang="en-GB">
                 <a:solidFill>
                   <a:schemeClr val="tx2"/>
                 </a:solidFill>
               </a:rPr>
-              <a:t>Result: </a:t>
-            </a:r>
-            <a:r>
-              <a:rPr sz="1200" b="0" lang="en-GB">
+              <a:t>No module named 'yaml'? </a:t>
+            </a:r>
+            <a:r>
+              <a:rPr sz="1100" b="0" lang="en-GB">
                 <a:solidFill>
                   <a:schemeClr val="tx1"/>
                 </a:solidFill>
               </a:rPr>
-              <a:t>a table, a chart, the coefficients</a:t>
-            </a:r>
-          </a:p>
-        </p:txBody>
-      </p:sp>
-      <p:sp>
-        <p:nvSpPr>
-          <p:cNvPr id="28" name="Test run box"/>
+              <a:t>Install into the .venv:</a:t>
+            </a:r>
+          </a:p>
+          <a:p>
+            <a:pPr algn="l">
+              <a:spcAft>
+                <a:spcPts val="200"/>
+              </a:spcAft>
+            </a:pPr>
+            <a:r>
+              <a:rPr sz="1050" b="0" lang="en-GB">
+                <a:solidFill>
+                  <a:schemeClr val="tx2"/>
+                </a:solidFill>
+                <a:latin typeface="Consolas"/>
+              </a:rPr>
+              <a:t>.venv\Scripts\python -m pip install …</a:t>
+            </a:r>
+          </a:p>
+        </p:txBody>
+      </p:sp>
+      <p:sp>
+        <p:nvSpPr>
+          <p:cNvPr id="29" name="Test run box"/>
           <p:cNvSpPr/>
           <p:nvPr/>
         </p:nvSpPr>
@@ -20511,7 +20569,7 @@
       </p:sp>
       <p:pic>
         <p:nvPicPr>
-          <p:cNvPr id="29" name="Icon Test run" descr=""/>
+          <p:cNvPr id="30" name="Icon Test run" descr=""/>
           <p:cNvPicPr>
             <a:picLocks noChangeAspect="1"/>
           </p:cNvPicPr>
@@ -20535,7 +20593,7 @@
       </p:pic>
       <p:sp>
         <p:nvSpPr>
-          <p:cNvPr id="30" name="Test run text"/>
+          <p:cNvPr id="31" name="Test run text"/>
           <p:cNvSpPr txBox="1"/>
           <p:nvPr/>
         </p:nvSpPr>
@@ -20574,7 +20632,7 @@
                   <a:schemeClr val="tx1"/>
                 </a:solidFill>
               </a:rPr>
-              <a:t>cell 1 once with Ctrl/Cmd + Enter, then Preview (Ctrl/Cmd + Shift + K).</a:t>
+              <a:t>pick Python 3.14.8 (.venv), run cell 1 once, then Preview (Ctrl/Cmd + Shift + K).</a:t>
             </a:r>
           </a:p>
         </p:txBody>
@@ -53028,7 +53086,7 @@
                     <a:p>
                       <a:r>
                         <a:rPr sz="1300" b="1" lang="en-GB"/>
-                        <a:t>Windows: python or py is not recognised</a:t>
+                        <a:t>Windows: py is not recognised</a:t>
                       </a:r>
                     </a:p>
                   </a:txBody>
@@ -53041,7 +53099,7 @@
                     <a:p>
                       <a:r>
                         <a:rPr sz="1300" lang="en-GB"/>
-                        <a:t>Reinstall the Python install manager, then run py install 3.14</a:t>
+                        <a:t>Reinstall the Python install manager; py install 3.14</a:t>
                       </a:r>
                     </a:p>
                   </a:txBody>
@@ -53056,7 +53114,7 @@
                     <a:p>
                       <a:r>
                         <a:rPr sz="1300" b="1" lang="en-GB"/>
-                        <a:t>No .venv in the Interpreter picker</a:t>
+                        <a:t>No .venv in the picker</a:t>
                       </a:r>
                     </a:p>
                   </a:txBody>
@@ -53069,7 +53127,7 @@
                     <a:p>
                       <a:r>
                         <a:rPr sz="1300" lang="en-GB"/>
-                        <a:t>Open the course folder, not a single file; then pick Python 3.14.8 (.venv)</a:t>
+                        <a:t>Open the course folder, not a file; pick Python 3.14.8 (.venv)</a:t>
                       </a:r>
                     </a:p>
                   </a:txBody>
@@ -53084,7 +53142,7 @@
                     <a:p>
                       <a:r>
                         <a:rPr sz="1300" b="1" lang="en-GB"/>
-                        <a:t>The check shows Python 3.13 or older</a:t>
+                        <a:t>Check shows Python 3.13 or older</a:t>
                       </a:r>
                     </a:p>
                   </a:txBody>
@@ -53112,7 +53170,7 @@
                     <a:p>
                       <a:r>
                         <a:rPr sz="1300" b="1" lang="en-GB"/>
-                        <a:t>ModuleNotFoundError</a:t>
+                        <a:t>No module named … (also 'yaml')</a:t>
                       </a:r>
                     </a:p>
                   </a:txBody>
@@ -53125,7 +53183,7 @@
                     <a:p>
                       <a:r>
                         <a:rPr sz="1300" lang="en-GB"/>
-                        <a:t>Select the .venv interpreter, then %pip install the package</a:t>
+                        <a:t>Not in the .venv: select it, then %pip install the package</a:t>
                       </a:r>
                     </a:p>
                   </a:txBody>
@@ -53140,7 +53198,7 @@
                     <a:p>
                       <a:r>
                         <a:rPr sz="1300" b="1" lang="en-GB"/>
-                        <a:t>macOS: externally-managed-environment</a:t>
+                        <a:t>macOS: externally-managed</a:t>
                       </a:r>
                     </a:p>
                   </a:txBody>
@@ -53153,7 +53211,7 @@
                     <a:p>
                       <a:r>
                         <a:rPr sz="1300" lang="en-GB"/>
-                        <a:t>You used the system Python: select the project's .venv first</a:t>
+                        <a:t>System Python in use: select the project's .venv</a:t>
                       </a:r>
                     </a:p>
                   </a:txBody>
@@ -53209,7 +53267,7 @@
                     <a:p>
                       <a:r>
                         <a:rPr sz="1300" lang="en-GB"/>
-                        <a:t>Sign in again under Accounts in the settings; check the URL</a:t>
+                        <a:t>Sign in again under Accounts in the settings</a:t>
                       </a:r>
                     </a:p>
                   </a:txBody>
@@ -53237,7 +53295,7 @@
                     <a:p>
                       <a:r>
                         <a:rPr sz="1300" lang="en-GB"/>
-                        <a:t>GitHub Education still pending: use Copilot Free meanwhile</a:t>
+                        <a:t>GitHub Education pending: use Copilot Free meanwhile</a:t>
                       </a:r>
                     </a:p>
                   </a:txBody>

</xml_diff>

<commit_message>
Set-up deck: download link for test_stack.qmd on the stack-test slide
Co-Authored-By: Claude Opus 5.5 <noreply@anthropic.com>
Claude-Session: https://claude.ai/code/session_01TbrdxHn7W6FVXXnpqzNytd
</commit_message>
<xml_diff>
--- a/slides/01a_setup-and-registration_WT26-27.pptx
+++ b/slides/01a_setup-and-registration_WT26-27.pptx
@@ -20533,8 +20533,8 @@
         </p:nvSpPr>
         <p:spPr>
           <a:xfrm>
-            <a:off x="457200" y="4663440"/>
-            <a:ext cx="8229600" cy="411480"/>
+            <a:off x="457200" y="4645152"/>
+            <a:ext cx="8229600" cy="475488"/>
           </a:xfrm>
           <a:prstGeom prst="rect">
             <a:avLst/>
@@ -20569,7 +20569,7 @@
       </p:sp>
       <p:pic>
         <p:nvPicPr>
-          <p:cNvPr id="30" name="Icon Test run" descr=""/>
+          <p:cNvPr id="30" name="Icon test download" descr=""/>
           <p:cNvPicPr>
             <a:picLocks noChangeAspect="1"/>
           </p:cNvPicPr>
@@ -20583,8 +20583,8 @@
         </p:blipFill>
         <p:spPr>
           <a:xfrm>
-            <a:off x="658368" y="4677156"/>
-            <a:ext cx="384048" cy="384048"/>
+            <a:off x="621792" y="4700016"/>
+            <a:ext cx="365760" cy="365760"/>
           </a:xfrm>
           <a:prstGeom prst="rect">
             <a:avLst/>
@@ -20599,8 +20599,8 @@
         </p:nvSpPr>
         <p:spPr>
           <a:xfrm>
-            <a:off x="1234440" y="4663440"/>
-            <a:ext cx="7269480" cy="411480"/>
+            <a:off x="1143000" y="4645152"/>
+            <a:ext cx="7452360" cy="475488"/>
           </a:xfrm>
           <a:prstGeom prst="rect">
             <a:avLst/>
@@ -20615,24 +20615,56 @@
           <a:p>
             <a:pPr algn="l">
               <a:spcAft>
-                <a:spcPts val="400"/>
+                <a:spcPts val="0"/>
               </a:spcAft>
             </a:pPr>
             <a:r>
-              <a:rPr sz="1300" b="1" lang="en-GB">
+              <a:rPr sz="1150" b="1" lang="en-GB">
                 <a:solidFill>
                   <a:schemeClr val="tx2"/>
                 </a:solidFill>
               </a:rPr>
+              <a:t>Download: </a:t>
+            </a:r>
+            <a:r>
+              <a:rPr sz="1150" b="0" lang="en-GB">
+                <a:solidFill>
+                  <a:schemeClr val="accent1"/>
+                </a:solidFill>
+                <a:hlinkClick r:id="rId4"/>
+              </a:rPr>
+              <a:t>test_stack.qmd on GitHub</a:t>
+            </a:r>
+            <a:r>
+              <a:rPr sz="1150" b="0" lang="en-GB">
+                <a:solidFill>
+                  <a:schemeClr val="tx1"/>
+                </a:solidFill>
+              </a:rPr>
+              <a:t> (button Download raw file) or on Canvas</a:t>
+            </a:r>
+          </a:p>
+          <a:p>
+            <a:pPr algn="l">
+              <a:spcAft>
+                <a:spcPts val="0"/>
+              </a:spcAft>
+            </a:pPr>
+            <a:r>
+              <a:rPr sz="1150" b="1" lang="en-GB">
+                <a:solidFill>
+                  <a:schemeClr val="tx2"/>
+                </a:solidFill>
+              </a:rPr>
               <a:t>Run it: </a:t>
             </a:r>
             <a:r>
-              <a:rPr sz="1300" b="0" lang="en-GB">
+              <a:rPr sz="1150" b="0" lang="en-GB">
                 <a:solidFill>
                   <a:schemeClr val="tx1"/>
                 </a:solidFill>
               </a:rPr>
-              <a:t>pick Python 3.14.8 (.venv), run cell 1 once, then Preview (Ctrl/Cmd + Shift + K).</a:t>
+              <a:t>pick Python 3.14.8 (.venv), run cell 1 once, then Preview (Ctrl/Cmd + Shift + K)</a:t>
             </a:r>
           </a:p>
         </p:txBody>

</xml_diff>